<commit_message>
bugs in ppt implementation fixed
- sidebar no longer shows the literal word "FOOTER" on new slides
- section number and titles shrink to fit instead of spilling off-slide
- inserted tables default to "No Style, No Grid"; data table keeps the
  branded style
- three-column panel greyed via the table's own cells, so an unused
  layout stays empty
- quote layouts gained an off-slide title placeholder (Outline view,
  Accessibility Checker)
- new "Content (no sidebar)" layout
- footer placeholders matched by type, not index 11, which had been
  leaking the sidebar text into the quote author line

Co-Authored-By: Claude Opus 5 <noreply@anthropic.com>
</commit_message>
<xml_diff>
--- a/pptx/unair-sample.pptx
+++ b/pptx/unair-sample.pptx
@@ -221,7 +221,7 @@
         </p:spPr>
         <p:txBody>
           <a:bodyPr wrap="square" lIns="0" tIns="0" rIns="0" bIns="0" anchor="b" rtlCol="0">
-            <a:noAutofit/>
+            <a:normAutofit/>
           </a:bodyPr>
           <a:lstStyle>
             <a:lvl1pPr marL="0" indent="0">
@@ -261,7 +261,7 @@
         </p:spPr>
         <p:txBody>
           <a:bodyPr wrap="square" lIns="0" tIns="0" rIns="0" bIns="0" anchor="t" rtlCol="0">
-            <a:noAutofit/>
+            <a:normAutofit/>
           </a:bodyPr>
           <a:lstStyle>
             <a:lvl1pPr marL="0" indent="0">
@@ -302,7 +302,7 @@
         </p:spPr>
         <p:txBody>
           <a:bodyPr wrap="square" lIns="0" tIns="0" rIns="0" bIns="0" anchor="t" rtlCol="0">
-            <a:noAutofit/>
+            <a:normAutofit/>
           </a:bodyPr>
           <a:lstStyle>
             <a:lvl1pPr marL="0" indent="0">
@@ -343,7 +343,7 @@
         </p:spPr>
         <p:txBody>
           <a:bodyPr wrap="square" lIns="0" tIns="0" rIns="0" bIns="0" anchor="t" rtlCol="0">
-            <a:noAutofit/>
+            <a:normAutofit/>
           </a:bodyPr>
           <a:lstStyle>
             <a:lvl1pPr marL="0" indent="0">
@@ -409,10 +409,286 @@
   <p:clrMapOvr>
     <a:masterClrMapping/>
   </p:clrMapOvr>
+  <p:hf ftr="0" sldNum="0" hdr="0" dt="0"/>
 </p:sldLayout>
 </file>
 
 <file path=ppt/slideLayouts/slideLayout10.xml><?xml version="1.0" encoding="utf-8"?>
+<p:sldLayout xmlns:a="http://schemas.openxmlformats.org/drawingml/2006/main" xmlns:r="http://schemas.openxmlformats.org/officeDocument/2006/relationships" xmlns:p="http://schemas.openxmlformats.org/presentationml/2006/main" preserve="1" userDrawn="1">
+  <p:cSld name="Text + Shaded Box">
+    <p:spTree>
+      <p:nvGrpSpPr>
+        <p:cNvPr id="1" name=""/>
+        <p:cNvGrpSpPr/>
+        <p:nvPr/>
+      </p:nvGrpSpPr>
+      <p:grpSpPr>
+        <a:xfrm>
+          <a:off x="0" y="0"/>
+          <a:ext cx="0" cy="0"/>
+          <a:chOff x="0" y="0"/>
+          <a:chExt cx="0" cy="0"/>
+        </a:xfrm>
+      </p:grpSpPr>
+      <p:pic>
+        <p:nvPicPr>
+          <p:cNvPr id="2" name="Logo" descr="Universitas Airlangga logo"/>
+          <p:cNvPicPr>
+            <a:picLocks noChangeAspect="1"/>
+          </p:cNvPicPr>
+          <p:nvPr userDrawn="1"/>
+        </p:nvPicPr>
+        <p:blipFill>
+          <a:blip r:embed="rId2"/>
+          <a:stretch>
+            <a:fillRect/>
+          </a:stretch>
+        </p:blipFill>
+        <p:spPr>
+          <a:xfrm>
+            <a:off x="9357055" y="256032"/>
+            <a:ext cx="1828800" cy="688562"/>
+          </a:xfrm>
+          <a:prstGeom prst="rect">
+            <a:avLst/>
+          </a:prstGeom>
+        </p:spPr>
+      </p:pic>
+      <p:sp>
+        <p:nvSpPr>
+          <p:cNvPr id="3" name="Title"/>
+          <p:cNvSpPr>
+            <a:spLocks noGrp="1"/>
+          </p:cNvSpPr>
+          <p:nvPr>
+            <p:ph type="title" hasCustomPrompt="1"/>
+          </p:nvPr>
+        </p:nvSpPr>
+        <p:spPr>
+          <a:xfrm>
+            <a:off x="548640" y="274320"/>
+            <a:ext cx="8503920" cy="841248"/>
+          </a:xfrm>
+          <a:prstGeom prst="rect">
+            <a:avLst/>
+          </a:prstGeom>
+        </p:spPr>
+        <p:txBody>
+          <a:bodyPr wrap="square" lIns="0" tIns="0" rIns="0" bIns="0" anchor="b" rtlCol="0">
+            <a:normAutofit/>
+          </a:bodyPr>
+          <a:lstStyle>
+            <a:lvl1pPr marL="0" indent="0">
+              <a:buNone/>
+              <a:defRPr lang="en-US"/>
+            </a:lvl1pPr>
+          </a:lstStyle>
+          <a:p>
+            <a:r>
+              <a:rPr lang="en-US"/>
+              <a:t>Click to edit title</a:t>
+            </a:r>
+          </a:p>
+        </p:txBody>
+      </p:sp>
+      <p:cxnSp>
+        <p:nvCxnSpPr>
+          <p:cNvPr id="4" name="Title rule"/>
+          <p:cNvCxnSpPr/>
+          <p:nvPr userDrawn="1"/>
+        </p:nvCxnSpPr>
+        <p:spPr>
+          <a:xfrm>
+            <a:off x="548640" y="1188720"/>
+            <a:ext cx="10545775" cy="0"/>
+          </a:xfrm>
+          <a:prstGeom prst="line">
+            <a:avLst/>
+          </a:prstGeom>
+          <a:ln w="28575">
+            <a:solidFill>
+              <a:srgbClr val="FFCB05"/>
+            </a:solidFill>
+          </a:ln>
+        </p:spPr>
+      </p:cxnSp>
+      <p:sp>
+        <p:nvSpPr>
+          <p:cNvPr id="5" name="Lead"/>
+          <p:cNvSpPr>
+            <a:spLocks noGrp="1"/>
+          </p:cNvSpPr>
+          <p:nvPr>
+            <p:ph type="body" idx="15" hasCustomPrompt="1"/>
+          </p:nvPr>
+        </p:nvSpPr>
+        <p:spPr>
+          <a:xfrm>
+            <a:off x="548640" y="1481328"/>
+            <a:ext cx="10545775" cy="1005840"/>
+          </a:xfrm>
+          <a:prstGeom prst="rect">
+            <a:avLst/>
+          </a:prstGeom>
+        </p:spPr>
+        <p:txBody>
+          <a:bodyPr wrap="square" lIns="0" tIns="0" rIns="0" bIns="0" anchor="t" rtlCol="0">
+            <a:normAutofit/>
+          </a:bodyPr>
+          <a:lstStyle>
+            <a:lvl1pPr marL="0" indent="0">
+              <a:lnSpc>
+                <a:spcPct val="115000"/>
+              </a:lnSpc>
+              <a:buNone/>
+              <a:defRPr lang="en-US" sz="2200">
+                <a:latin typeface="Segoe UI Light"/>
+              </a:defRPr>
+            </a:lvl1pPr>
+          </a:lstStyle>
+          <a:p>
+            <a:r>
+              <a:rPr lang="en-US"/>
+              <a:t>Introductory sentence</a:t>
+            </a:r>
+          </a:p>
+        </p:txBody>
+      </p:sp>
+      <p:sp>
+        <p:nvSpPr>
+          <p:cNvPr id="6" name="Box accent"/>
+          <p:cNvSpPr/>
+          <p:nvPr userDrawn="1"/>
+        </p:nvSpPr>
+        <p:spPr>
+          <a:xfrm>
+            <a:off x="548640" y="2697480"/>
+            <a:ext cx="10545775" cy="3520440"/>
+          </a:xfrm>
+          <a:prstGeom prst="roundRect">
+            <a:avLst>
+              <a:gd name="adj" fmla="val 2500"/>
+            </a:avLst>
+          </a:prstGeom>
+          <a:solidFill>
+            <a:srgbClr val="FFCB05"/>
+          </a:solidFill>
+          <a:ln>
+            <a:noFill/>
+          </a:ln>
+        </p:spPr>
+      </p:sp>
+      <p:sp>
+        <p:nvSpPr>
+          <p:cNvPr id="7" name="Box"/>
+          <p:cNvSpPr/>
+          <p:nvPr userDrawn="1"/>
+        </p:nvSpPr>
+        <p:spPr>
+          <a:xfrm>
+            <a:off x="621792" y="2697480"/>
+            <a:ext cx="10472623" cy="3520440"/>
+          </a:xfrm>
+          <a:prstGeom prst="roundRect">
+            <a:avLst>
+              <a:gd name="adj" fmla="val 2500"/>
+            </a:avLst>
+          </a:prstGeom>
+          <a:solidFill>
+            <a:srgbClr val="F0F0F0"/>
+          </a:solidFill>
+          <a:ln>
+            <a:noFill/>
+          </a:ln>
+        </p:spPr>
+      </p:sp>
+      <p:sp>
+        <p:nvSpPr>
+          <p:cNvPr id="8" name="Box text"/>
+          <p:cNvSpPr>
+            <a:spLocks noGrp="1"/>
+          </p:cNvSpPr>
+          <p:nvPr>
+            <p:ph type="body" idx="16" hasCustomPrompt="1"/>
+          </p:nvPr>
+        </p:nvSpPr>
+        <p:spPr>
+          <a:xfrm>
+            <a:off x="1051560" y="3063240"/>
+            <a:ext cx="9539935" cy="2788920"/>
+          </a:xfrm>
+          <a:prstGeom prst="rect">
+            <a:avLst/>
+          </a:prstGeom>
+        </p:spPr>
+        <p:txBody>
+          <a:bodyPr wrap="square" lIns="0" tIns="0" rIns="0" bIns="0" anchor="t" rtlCol="0">
+            <a:normAutofit/>
+          </a:bodyPr>
+          <a:lstStyle>
+            <a:lvl1pPr marL="0" indent="0">
+              <a:lnSpc>
+                <a:spcPct val="130000"/>
+              </a:lnSpc>
+              <a:buNone/>
+              <a:defRPr lang="en-US" sz="1700"/>
+            </a:lvl1pPr>
+          </a:lstStyle>
+          <a:p>
+            <a:r>
+              <a:rPr lang="en-US"/>
+              <a:t>Supporting detail</a:t>
+            </a:r>
+          </a:p>
+        </p:txBody>
+      </p:sp>
+      <p:sp>
+        <p:nvSpPr>
+          <p:cNvPr id="9" name="Footer Placeholder"/>
+          <p:cNvSpPr>
+            <a:spLocks noGrp="1"/>
+          </p:cNvSpPr>
+          <p:nvPr>
+            <p:ph type="ftr" idx="11"/>
+          </p:nvPr>
+        </p:nvSpPr>
+        <p:spPr>
+          <a:xfrm rot="16200000">
+            <a:off x="9745675" y="3429000"/>
+            <a:ext cx="4206240" cy="274320"/>
+          </a:xfrm>
+          <a:prstGeom prst="rect">
+            <a:avLst/>
+          </a:prstGeom>
+        </p:spPr>
+        <p:txBody>
+          <a:bodyPr wrap="square" lIns="0" tIns="0" rIns="0" bIns="0" anchor="ctr" rtlCol="0">
+            <a:noAutofit/>
+          </a:bodyPr>
+          <a:lstStyle>
+            <a:lvl1pPr marL="0" indent="0" algn="ctr">
+              <a:buNone/>
+              <a:defRPr lang="en-US" sz="850" b="1" cap="all" spc="190">
+                <a:solidFill>
+                  <a:srgbClr val="FFFFFF"/>
+                </a:solidFill>
+              </a:defRPr>
+            </a:lvl1pPr>
+          </a:lstStyle>
+          <a:p>
+            <a:endParaRPr lang="en-US"/>
+          </a:p>
+        </p:txBody>
+      </p:sp>
+    </p:spTree>
+  </p:cSld>
+  <p:clrMapOvr>
+    <a:masterClrMapping/>
+  </p:clrMapOvr>
+</p:sldLayout>
+</file>
+
+<file path=ppt/slideLayouts/slideLayout11.xml><?xml version="1.0" encoding="utf-8"?>
 <p:sldLayout xmlns:a="http://schemas.openxmlformats.org/drawingml/2006/main" xmlns:r="http://schemas.openxmlformats.org/officeDocument/2006/relationships" xmlns:p="http://schemas.openxmlformats.org/presentationml/2006/main" preserve="1" userDrawn="1">
   <p:cSld name="Three Columns">
     <p:spTree>
@@ -474,7 +750,7 @@
         </p:spPr>
         <p:txBody>
           <a:bodyPr wrap="square" lIns="0" tIns="0" rIns="0" bIns="0" anchor="b" rtlCol="0">
-            <a:noAutofit/>
+            <a:normAutofit/>
           </a:bodyPr>
           <a:lstStyle>
             <a:lvl1pPr marL="0" indent="0">
@@ -532,7 +808,7 @@
         </p:spPr>
         <p:txBody>
           <a:bodyPr wrap="square" lIns="0" tIns="0" rIns="0" bIns="0" anchor="t" rtlCol="0">
-            <a:noAutofit/>
+            <a:normAutofit/>
           </a:bodyPr>
           <a:lstStyle>
             <a:lvl1pPr marL="0" indent="0">
@@ -552,42 +828,18 @@
       </p:sp>
       <p:sp>
         <p:nvSpPr>
-          <p:cNvPr id="6" name="Panel"/>
-          <p:cNvSpPr/>
-          <p:nvPr userDrawn="1"/>
+          <p:cNvPr id="6" name="Columns"/>
+          <p:cNvSpPr>
+            <a:spLocks noGrp="1"/>
+          </p:cNvSpPr>
+          <p:nvPr>
+            <p:ph type="tbl" idx="20"/>
+          </p:nvPr>
         </p:nvSpPr>
         <p:spPr>
           <a:xfrm>
             <a:off x="548640" y="2286000"/>
             <a:ext cx="10545775" cy="4023360"/>
-          </a:xfrm>
-          <a:prstGeom prst="roundRect">
-            <a:avLst>
-              <a:gd name="adj" fmla="val 2500"/>
-            </a:avLst>
-          </a:prstGeom>
-          <a:solidFill>
-            <a:srgbClr val="F0F0F0"/>
-          </a:solidFill>
-          <a:ln>
-            <a:noFill/>
-          </a:ln>
-        </p:spPr>
-      </p:sp>
-      <p:sp>
-        <p:nvSpPr>
-          <p:cNvPr id="7" name="Icon 1"/>
-          <p:cNvSpPr>
-            <a:spLocks noGrp="1"/>
-          </p:cNvSpPr>
-          <p:nvPr>
-            <p:ph type="pic" idx="30" hasCustomPrompt="1"/>
-          </p:nvPr>
-        </p:nvSpPr>
-        <p:spPr>
-          <a:xfrm>
-            <a:off x="2077669" y="2697480"/>
-            <a:ext cx="731520" cy="731520"/>
           </a:xfrm>
           <a:prstGeom prst="rect">
             <a:avLst/>
@@ -600,7 +852,7 @@
           <a:lstStyle>
             <a:lvl1pPr marL="0" indent="0" algn="ctr">
               <a:buNone/>
-              <a:defRPr lang="en-US" sz="900">
+              <a:defRPr lang="en-US" sz="1200">
                 <a:solidFill>
                   <a:srgbClr val="666666"/>
                 </a:solidFill>
@@ -608,27 +860,24 @@
             </a:lvl1pPr>
           </a:lstStyle>
           <a:p>
-            <a:r>
-              <a:rPr lang="en-US"/>
-              <a:t>Icon</a:t>
-            </a:r>
-          </a:p>
-        </p:txBody>
-      </p:sp>
-      <p:sp>
-        <p:nvSpPr>
-          <p:cNvPr id="8" name="Heading 1"/>
-          <p:cNvSpPr>
-            <a:spLocks noGrp="1"/>
-          </p:cNvSpPr>
-          <p:nvPr>
-            <p:ph type="body" idx="40" hasCustomPrompt="1"/>
-          </p:nvPr>
-        </p:nvSpPr>
-        <p:spPr>
-          <a:xfrm>
-            <a:off x="960120" y="3566160"/>
-            <a:ext cx="2966618" cy="457200"/>
+            <a:endParaRPr lang="en-US"/>
+          </a:p>
+        </p:txBody>
+      </p:sp>
+      <p:sp>
+        <p:nvSpPr>
+          <p:cNvPr id="7" name="Footer Placeholder"/>
+          <p:cNvSpPr>
+            <a:spLocks noGrp="1"/>
+          </p:cNvSpPr>
+          <p:nvPr>
+            <p:ph type="ftr" idx="11"/>
+          </p:nvPr>
+        </p:nvSpPr>
+        <p:spPr>
+          <a:xfrm rot="16200000">
+            <a:off x="9745675" y="3429000"/>
+            <a:ext cx="4206240" cy="274320"/>
           </a:xfrm>
           <a:prstGeom prst="rect">
             <a:avLst/>
@@ -641,302 +890,15 @@
           <a:lstStyle>
             <a:lvl1pPr marL="0" indent="0" algn="ctr">
               <a:buNone/>
-              <a:defRPr lang="en-US" sz="1700" b="1">
+              <a:defRPr lang="en-US" sz="850" b="1" cap="all" spc="190">
                 <a:solidFill>
-                  <a:srgbClr val="14497F"/>
+                  <a:srgbClr val="FFFFFF"/>
                 </a:solidFill>
               </a:defRPr>
             </a:lvl1pPr>
           </a:lstStyle>
           <a:p>
-            <a:r>
-              <a:rPr lang="en-US"/>
-              <a:t>Heading</a:t>
-            </a:r>
-          </a:p>
-        </p:txBody>
-      </p:sp>
-      <p:sp>
-        <p:nvSpPr>
-          <p:cNvPr id="9" name="Text 1"/>
-          <p:cNvSpPr>
-            <a:spLocks noGrp="1"/>
-          </p:cNvSpPr>
-          <p:nvPr>
-            <p:ph type="body" idx="50" hasCustomPrompt="1"/>
-          </p:nvPr>
-        </p:nvSpPr>
-        <p:spPr>
-          <a:xfrm>
-            <a:off x="960120" y="4069080"/>
-            <a:ext cx="2966618" cy="1920240"/>
-          </a:xfrm>
-          <a:prstGeom prst="rect">
-            <a:avLst/>
-          </a:prstGeom>
-        </p:spPr>
-        <p:txBody>
-          <a:bodyPr wrap="square" lIns="0" tIns="0" rIns="0" bIns="0" anchor="t" rtlCol="0">
-            <a:normAutofit/>
-          </a:bodyPr>
-          <a:lstStyle>
-            <a:lvl1pPr marL="0" indent="0" algn="ctr">
-              <a:lnSpc>
-                <a:spcPct val="120000"/>
-              </a:lnSpc>
-              <a:buNone/>
-              <a:defRPr lang="en-US" sz="1400"/>
-            </a:lvl1pPr>
-          </a:lstStyle>
-          <a:p>
-            <a:r>
-              <a:rPr lang="en-US"/>
-              <a:t>Short description</a:t>
-            </a:r>
-          </a:p>
-        </p:txBody>
-      </p:sp>
-      <p:sp>
-        <p:nvSpPr>
-          <p:cNvPr id="10" name="Icon 2"/>
-          <p:cNvSpPr>
-            <a:spLocks noGrp="1"/>
-          </p:cNvSpPr>
-          <p:nvPr>
-            <p:ph type="pic" idx="31" hasCustomPrompt="1"/>
-          </p:nvPr>
-        </p:nvSpPr>
-        <p:spPr>
-          <a:xfrm>
-            <a:off x="5455768" y="2697480"/>
-            <a:ext cx="731520" cy="731520"/>
-          </a:xfrm>
-          <a:prstGeom prst="rect">
-            <a:avLst/>
-          </a:prstGeom>
-        </p:spPr>
-        <p:txBody>
-          <a:bodyPr wrap="square" lIns="0" tIns="0" rIns="0" bIns="0" anchor="ctr" rtlCol="0">
-            <a:noAutofit/>
-          </a:bodyPr>
-          <a:lstStyle>
-            <a:lvl1pPr marL="0" indent="0" algn="ctr">
-              <a:buNone/>
-              <a:defRPr lang="en-US" sz="900">
-                <a:solidFill>
-                  <a:srgbClr val="666666"/>
-                </a:solidFill>
-              </a:defRPr>
-            </a:lvl1pPr>
-          </a:lstStyle>
-          <a:p>
-            <a:r>
-              <a:rPr lang="en-US"/>
-              <a:t>Icon</a:t>
-            </a:r>
-          </a:p>
-        </p:txBody>
-      </p:sp>
-      <p:sp>
-        <p:nvSpPr>
-          <p:cNvPr id="11" name="Heading 2"/>
-          <p:cNvSpPr>
-            <a:spLocks noGrp="1"/>
-          </p:cNvSpPr>
-          <p:nvPr>
-            <p:ph type="body" idx="41" hasCustomPrompt="1"/>
-          </p:nvPr>
-        </p:nvSpPr>
-        <p:spPr>
-          <a:xfrm>
-            <a:off x="4338218" y="3566160"/>
-            <a:ext cx="2966618" cy="457200"/>
-          </a:xfrm>
-          <a:prstGeom prst="rect">
-            <a:avLst/>
-          </a:prstGeom>
-        </p:spPr>
-        <p:txBody>
-          <a:bodyPr wrap="square" lIns="0" tIns="0" rIns="0" bIns="0" anchor="ctr" rtlCol="0">
-            <a:noAutofit/>
-          </a:bodyPr>
-          <a:lstStyle>
-            <a:lvl1pPr marL="0" indent="0" algn="ctr">
-              <a:buNone/>
-              <a:defRPr lang="en-US" sz="1700" b="1">
-                <a:solidFill>
-                  <a:srgbClr val="14497F"/>
-                </a:solidFill>
-              </a:defRPr>
-            </a:lvl1pPr>
-          </a:lstStyle>
-          <a:p>
-            <a:r>
-              <a:rPr lang="en-US"/>
-              <a:t>Heading</a:t>
-            </a:r>
-          </a:p>
-        </p:txBody>
-      </p:sp>
-      <p:sp>
-        <p:nvSpPr>
-          <p:cNvPr id="12" name="Text 2"/>
-          <p:cNvSpPr>
-            <a:spLocks noGrp="1"/>
-          </p:cNvSpPr>
-          <p:nvPr>
-            <p:ph type="body" idx="51" hasCustomPrompt="1"/>
-          </p:nvPr>
-        </p:nvSpPr>
-        <p:spPr>
-          <a:xfrm>
-            <a:off x="4338218" y="4069080"/>
-            <a:ext cx="2966618" cy="1920240"/>
-          </a:xfrm>
-          <a:prstGeom prst="rect">
-            <a:avLst/>
-          </a:prstGeom>
-        </p:spPr>
-        <p:txBody>
-          <a:bodyPr wrap="square" lIns="0" tIns="0" rIns="0" bIns="0" anchor="t" rtlCol="0">
-            <a:normAutofit/>
-          </a:bodyPr>
-          <a:lstStyle>
-            <a:lvl1pPr marL="0" indent="0" algn="ctr">
-              <a:lnSpc>
-                <a:spcPct val="120000"/>
-              </a:lnSpc>
-              <a:buNone/>
-              <a:defRPr lang="en-US" sz="1400"/>
-            </a:lvl1pPr>
-          </a:lstStyle>
-          <a:p>
-            <a:r>
-              <a:rPr lang="en-US"/>
-              <a:t>Short description</a:t>
-            </a:r>
-          </a:p>
-        </p:txBody>
-      </p:sp>
-      <p:sp>
-        <p:nvSpPr>
-          <p:cNvPr id="13" name="Icon 3"/>
-          <p:cNvSpPr>
-            <a:spLocks noGrp="1"/>
-          </p:cNvSpPr>
-          <p:nvPr>
-            <p:ph type="pic" idx="32" hasCustomPrompt="1"/>
-          </p:nvPr>
-        </p:nvSpPr>
-        <p:spPr>
-          <a:xfrm>
-            <a:off x="8833866" y="2697480"/>
-            <a:ext cx="731520" cy="731520"/>
-          </a:xfrm>
-          <a:prstGeom prst="rect">
-            <a:avLst/>
-          </a:prstGeom>
-        </p:spPr>
-        <p:txBody>
-          <a:bodyPr wrap="square" lIns="0" tIns="0" rIns="0" bIns="0" anchor="ctr" rtlCol="0">
-            <a:noAutofit/>
-          </a:bodyPr>
-          <a:lstStyle>
-            <a:lvl1pPr marL="0" indent="0" algn="ctr">
-              <a:buNone/>
-              <a:defRPr lang="en-US" sz="900">
-                <a:solidFill>
-                  <a:srgbClr val="666666"/>
-                </a:solidFill>
-              </a:defRPr>
-            </a:lvl1pPr>
-          </a:lstStyle>
-          <a:p>
-            <a:r>
-              <a:rPr lang="en-US"/>
-              <a:t>Icon</a:t>
-            </a:r>
-          </a:p>
-        </p:txBody>
-      </p:sp>
-      <p:sp>
-        <p:nvSpPr>
-          <p:cNvPr id="14" name="Heading 3"/>
-          <p:cNvSpPr>
-            <a:spLocks noGrp="1"/>
-          </p:cNvSpPr>
-          <p:nvPr>
-            <p:ph type="body" idx="42" hasCustomPrompt="1"/>
-          </p:nvPr>
-        </p:nvSpPr>
-        <p:spPr>
-          <a:xfrm>
-            <a:off x="7716317" y="3566160"/>
-            <a:ext cx="2966618" cy="457200"/>
-          </a:xfrm>
-          <a:prstGeom prst="rect">
-            <a:avLst/>
-          </a:prstGeom>
-        </p:spPr>
-        <p:txBody>
-          <a:bodyPr wrap="square" lIns="0" tIns="0" rIns="0" bIns="0" anchor="ctr" rtlCol="0">
-            <a:noAutofit/>
-          </a:bodyPr>
-          <a:lstStyle>
-            <a:lvl1pPr marL="0" indent="0" algn="ctr">
-              <a:buNone/>
-              <a:defRPr lang="en-US" sz="1700" b="1">
-                <a:solidFill>
-                  <a:srgbClr val="14497F"/>
-                </a:solidFill>
-              </a:defRPr>
-            </a:lvl1pPr>
-          </a:lstStyle>
-          <a:p>
-            <a:r>
-              <a:rPr lang="en-US"/>
-              <a:t>Heading</a:t>
-            </a:r>
-          </a:p>
-        </p:txBody>
-      </p:sp>
-      <p:sp>
-        <p:nvSpPr>
-          <p:cNvPr id="15" name="Text 3"/>
-          <p:cNvSpPr>
-            <a:spLocks noGrp="1"/>
-          </p:cNvSpPr>
-          <p:nvPr>
-            <p:ph type="body" idx="52" hasCustomPrompt="1"/>
-          </p:nvPr>
-        </p:nvSpPr>
-        <p:spPr>
-          <a:xfrm>
-            <a:off x="7716317" y="4069080"/>
-            <a:ext cx="2966618" cy="1920240"/>
-          </a:xfrm>
-          <a:prstGeom prst="rect">
-            <a:avLst/>
-          </a:prstGeom>
-        </p:spPr>
-        <p:txBody>
-          <a:bodyPr wrap="square" lIns="0" tIns="0" rIns="0" bIns="0" anchor="t" rtlCol="0">
-            <a:normAutofit/>
-          </a:bodyPr>
-          <a:lstStyle>
-            <a:lvl1pPr marL="0" indent="0" algn="ctr">
-              <a:lnSpc>
-                <a:spcPct val="120000"/>
-              </a:lnSpc>
-              <a:buNone/>
-              <a:defRPr lang="en-US" sz="1400"/>
-            </a:lvl1pPr>
-          </a:lstStyle>
-          <a:p>
-            <a:r>
-              <a:rPr lang="en-US"/>
-              <a:t>Short description</a:t>
-            </a:r>
+            <a:endParaRPr lang="en-US"/>
           </a:p>
         </p:txBody>
       </p:sp>
@@ -948,7 +910,7 @@
 </p:sldLayout>
 </file>
 
-<file path=ppt/slideLayouts/slideLayout11.xml><?xml version="1.0" encoding="utf-8"?>
+<file path=ppt/slideLayouts/slideLayout12.xml><?xml version="1.0" encoding="utf-8"?>
 <p:sldLayout xmlns:a="http://schemas.openxmlformats.org/drawingml/2006/main" xmlns:r="http://schemas.openxmlformats.org/officeDocument/2006/relationships" xmlns:p="http://schemas.openxmlformats.org/presentationml/2006/main" preserve="1" userDrawn="1">
   <p:cSld name="Overview Grid">
     <p:spTree>
@@ -1008,7 +970,7 @@
         </p:spPr>
         <p:txBody>
           <a:bodyPr wrap="square" lIns="0" tIns="0" rIns="0" bIns="0" anchor="ctr" rtlCol="0">
-            <a:noAutofit/>
+            <a:normAutofit/>
           </a:bodyPr>
           <a:lstStyle>
             <a:lvl1pPr marL="0" indent="0" algn="ctr">
@@ -1035,7 +997,7 @@
             <a:spLocks noGrp="1"/>
           </p:cNvSpPr>
           <p:nvPr>
-            <p:ph type="pic" idx="10" hasCustomPrompt="1"/>
+            <p:ph type="pic" idx="15" hasCustomPrompt="1"/>
           </p:nvPr>
         </p:nvSpPr>
         <p:spPr>
@@ -1090,7 +1052,7 @@
         </p:spPr>
         <p:txBody>
           <a:bodyPr wrap="square" lIns="0" tIns="0" rIns="0" bIns="0" anchor="t" rtlCol="0">
-            <a:noAutofit/>
+            <a:normAutofit/>
           </a:bodyPr>
           <a:lstStyle>
             <a:lvl1pPr marL="0" indent="0" algn="ctr">
@@ -1113,7 +1075,7 @@
             <a:spLocks noGrp="1"/>
           </p:cNvSpPr>
           <p:nvPr>
-            <p:ph type="pic" idx="11" hasCustomPrompt="1"/>
+            <p:ph type="pic" idx="16" hasCustomPrompt="1"/>
           </p:nvPr>
         </p:nvSpPr>
         <p:spPr>
@@ -1168,7 +1130,7 @@
         </p:spPr>
         <p:txBody>
           <a:bodyPr wrap="square" lIns="0" tIns="0" rIns="0" bIns="0" anchor="t" rtlCol="0">
-            <a:noAutofit/>
+            <a:normAutofit/>
           </a:bodyPr>
           <a:lstStyle>
             <a:lvl1pPr marL="0" indent="0" algn="ctr">
@@ -1191,7 +1153,7 @@
             <a:spLocks noGrp="1"/>
           </p:cNvSpPr>
           <p:nvPr>
-            <p:ph type="pic" idx="12" hasCustomPrompt="1"/>
+            <p:ph type="pic" idx="17" hasCustomPrompt="1"/>
           </p:nvPr>
         </p:nvSpPr>
         <p:spPr>
@@ -1246,7 +1208,7 @@
         </p:spPr>
         <p:txBody>
           <a:bodyPr wrap="square" lIns="0" tIns="0" rIns="0" bIns="0" anchor="t" rtlCol="0">
-            <a:noAutofit/>
+            <a:normAutofit/>
           </a:bodyPr>
           <a:lstStyle>
             <a:lvl1pPr marL="0" indent="0" algn="ctr">
@@ -1259,6 +1221,44 @@
               <a:rPr lang="en-US"/>
               <a:t>Caption</a:t>
             </a:r>
+          </a:p>
+        </p:txBody>
+      </p:sp>
+      <p:sp>
+        <p:nvSpPr>
+          <p:cNvPr id="10" name="Footer Placeholder"/>
+          <p:cNvSpPr>
+            <a:spLocks noGrp="1"/>
+          </p:cNvSpPr>
+          <p:nvPr>
+            <p:ph type="ftr" idx="11"/>
+          </p:nvPr>
+        </p:nvSpPr>
+        <p:spPr>
+          <a:xfrm rot="16200000">
+            <a:off x="9745675" y="3429000"/>
+            <a:ext cx="4206240" cy="274320"/>
+          </a:xfrm>
+          <a:prstGeom prst="rect">
+            <a:avLst/>
+          </a:prstGeom>
+        </p:spPr>
+        <p:txBody>
+          <a:bodyPr wrap="square" lIns="0" tIns="0" rIns="0" bIns="0" anchor="ctr" rtlCol="0">
+            <a:noAutofit/>
+          </a:bodyPr>
+          <a:lstStyle>
+            <a:lvl1pPr marL="0" indent="0" algn="ctr">
+              <a:buNone/>
+              <a:defRPr lang="en-US" sz="850" b="1" cap="all" spc="190">
+                <a:solidFill>
+                  <a:srgbClr val="FFFFFF"/>
+                </a:solidFill>
+              </a:defRPr>
+            </a:lvl1pPr>
+          </a:lstStyle>
+          <a:p>
+            <a:endParaRPr lang="en-US"/>
           </a:p>
         </p:txBody>
       </p:sp>
@@ -1270,7 +1270,7 @@
 </p:sldLayout>
 </file>
 
-<file path=ppt/slideLayouts/slideLayout12.xml><?xml version="1.0" encoding="utf-8"?>
+<file path=ppt/slideLayouts/slideLayout13.xml><?xml version="1.0" encoding="utf-8"?>
 <p:sldLayout xmlns:a="http://schemas.openxmlformats.org/drawingml/2006/main" xmlns:r="http://schemas.openxmlformats.org/officeDocument/2006/relationships" xmlns:p="http://schemas.openxmlformats.org/presentationml/2006/main" preserve="1" userDrawn="1" showMasterSp="0">
   <p:cSld name="Quote">
     <p:bg>
@@ -1297,7 +1297,48 @@
       </p:grpSpPr>
       <p:sp>
         <p:nvSpPr>
-          <p:cNvPr id="2" name="Quote mark"/>
+          <p:cNvPr id="2" name="Title"/>
+          <p:cNvSpPr>
+            <a:spLocks noGrp="1"/>
+          </p:cNvSpPr>
+          <p:nvPr>
+            <p:ph type="title" hasCustomPrompt="1"/>
+          </p:nvPr>
+        </p:nvSpPr>
+        <p:spPr>
+          <a:xfrm>
+            <a:off x="-4023360" y="365760"/>
+            <a:ext cx="3474720" cy="731520"/>
+          </a:xfrm>
+          <a:prstGeom prst="rect">
+            <a:avLst/>
+          </a:prstGeom>
+        </p:spPr>
+        <p:txBody>
+          <a:bodyPr wrap="square" lIns="0" tIns="0" rIns="0" bIns="0" anchor="t" rtlCol="0">
+            <a:normAutofit/>
+          </a:bodyPr>
+          <a:lstStyle>
+            <a:lvl1pPr marL="0" indent="0">
+              <a:buNone/>
+              <a:defRPr lang="en-US" sz="2400">
+                <a:solidFill>
+                  <a:srgbClr val="14497F"/>
+                </a:solidFill>
+              </a:defRPr>
+            </a:lvl1pPr>
+          </a:lstStyle>
+          <a:p>
+            <a:r>
+              <a:rPr lang="en-US"/>
+              <a:t>Slide title (not shown on the slide)</a:t>
+            </a:r>
+          </a:p>
+        </p:txBody>
+      </p:sp>
+      <p:sp>
+        <p:nvSpPr>
+          <p:cNvPr id="3" name="Quote mark"/>
           <p:cNvSpPr txBox="1"/>
           <p:nvPr userDrawn="1"/>
         </p:nvSpPr>
@@ -1331,7 +1372,7 @@
       </p:sp>
       <p:sp>
         <p:nvSpPr>
-          <p:cNvPr id="3" name="Quote rule"/>
+          <p:cNvPr id="4" name="Quote rule"/>
           <p:cNvSpPr/>
           <p:nvPr userDrawn="1"/>
         </p:nvSpPr>
@@ -1353,7 +1394,7 @@
       </p:sp>
       <p:sp>
         <p:nvSpPr>
-          <p:cNvPr id="4" name="Quote"/>
+          <p:cNvPr id="5" name="Quote"/>
           <p:cNvSpPr>
             <a:spLocks noGrp="1"/>
           </p:cNvSpPr>
@@ -1397,7 +1438,7 @@
       </p:sp>
       <p:sp>
         <p:nvSpPr>
-          <p:cNvPr id="5" name="Author"/>
+          <p:cNvPr id="6" name="Author"/>
           <p:cNvSpPr>
             <a:spLocks noGrp="1"/>
           </p:cNvSpPr>
@@ -1416,7 +1457,7 @@
         </p:spPr>
         <p:txBody>
           <a:bodyPr wrap="square" lIns="0" tIns="0" rIns="0" bIns="0" anchor="b" rtlCol="0">
-            <a:noAutofit/>
+            <a:normAutofit/>
           </a:bodyPr>
           <a:lstStyle>
             <a:lvl1pPr marL="0" indent="0">
@@ -1441,10 +1482,11 @@
   <p:clrMapOvr>
     <a:masterClrMapping/>
   </p:clrMapOvr>
+  <p:hf ftr="0" sldNum="0" hdr="0" dt="0"/>
 </p:sldLayout>
 </file>
 
-<file path=ppt/slideLayouts/slideLayout13.xml><?xml version="1.0" encoding="utf-8"?>
+<file path=ppt/slideLayouts/slideLayout14.xml><?xml version="1.0" encoding="utf-8"?>
 <p:sldLayout xmlns:a="http://schemas.openxmlformats.org/drawingml/2006/main" xmlns:r="http://schemas.openxmlformats.org/officeDocument/2006/relationships" xmlns:p="http://schemas.openxmlformats.org/presentationml/2006/main" preserve="1" userDrawn="1" showMasterSp="0">
   <p:cSld name="Quote (Dark / Photo)">
     <p:bg>
@@ -1501,7 +1543,48 @@
       </p:pic>
       <p:sp>
         <p:nvSpPr>
-          <p:cNvPr id="3" name="Quote mark"/>
+          <p:cNvPr id="3" name="Title"/>
+          <p:cNvSpPr>
+            <a:spLocks noGrp="1"/>
+          </p:cNvSpPr>
+          <p:nvPr>
+            <p:ph type="title" hasCustomPrompt="1"/>
+          </p:nvPr>
+        </p:nvSpPr>
+        <p:spPr>
+          <a:xfrm>
+            <a:off x="-4023360" y="365760"/>
+            <a:ext cx="3474720" cy="731520"/>
+          </a:xfrm>
+          <a:prstGeom prst="rect">
+            <a:avLst/>
+          </a:prstGeom>
+        </p:spPr>
+        <p:txBody>
+          <a:bodyPr wrap="square" lIns="0" tIns="0" rIns="0" bIns="0" anchor="t" rtlCol="0">
+            <a:normAutofit/>
+          </a:bodyPr>
+          <a:lstStyle>
+            <a:lvl1pPr marL="0" indent="0">
+              <a:buNone/>
+              <a:defRPr lang="en-US" sz="2400">
+                <a:solidFill>
+                  <a:srgbClr val="14497F"/>
+                </a:solidFill>
+              </a:defRPr>
+            </a:lvl1pPr>
+          </a:lstStyle>
+          <a:p>
+            <a:r>
+              <a:rPr lang="en-US"/>
+              <a:t>Slide title (not shown on the slide)</a:t>
+            </a:r>
+          </a:p>
+        </p:txBody>
+      </p:sp>
+      <p:sp>
+        <p:nvSpPr>
+          <p:cNvPr id="4" name="Quote mark"/>
           <p:cNvSpPr txBox="1"/>
           <p:nvPr userDrawn="1"/>
         </p:nvSpPr>
@@ -1535,7 +1618,7 @@
       </p:sp>
       <p:sp>
         <p:nvSpPr>
-          <p:cNvPr id="4" name="Quote rule"/>
+          <p:cNvPr id="5" name="Quote rule"/>
           <p:cNvSpPr/>
           <p:nvPr userDrawn="1"/>
         </p:nvSpPr>
@@ -1557,7 +1640,7 @@
       </p:sp>
       <p:sp>
         <p:nvSpPr>
-          <p:cNvPr id="5" name="Quote"/>
+          <p:cNvPr id="6" name="Quote"/>
           <p:cNvSpPr>
             <a:spLocks noGrp="1"/>
           </p:cNvSpPr>
@@ -1602,7 +1685,7 @@
       </p:sp>
       <p:sp>
         <p:nvSpPr>
-          <p:cNvPr id="6" name="Author"/>
+          <p:cNvPr id="7" name="Author"/>
           <p:cNvSpPr>
             <a:spLocks noGrp="1"/>
           </p:cNvSpPr>
@@ -1621,7 +1704,7 @@
         </p:spPr>
         <p:txBody>
           <a:bodyPr wrap="square" lIns="0" tIns="0" rIns="0" bIns="0" anchor="b" rtlCol="0">
-            <a:noAutofit/>
+            <a:normAutofit/>
           </a:bodyPr>
           <a:lstStyle>
             <a:lvl1pPr marL="0" indent="0">
@@ -1646,10 +1729,11 @@
   <p:clrMapOvr>
     <a:masterClrMapping/>
   </p:clrMapOvr>
+  <p:hf ftr="0" sldNum="0" hdr="0" dt="0"/>
 </p:sldLayout>
 </file>
 
-<file path=ppt/slideLayouts/slideLayout14.xml><?xml version="1.0" encoding="utf-8"?>
+<file path=ppt/slideLayouts/slideLayout15.xml><?xml version="1.0" encoding="utf-8"?>
 <p:sldLayout xmlns:a="http://schemas.openxmlformats.org/drawingml/2006/main" xmlns:r="http://schemas.openxmlformats.org/officeDocument/2006/relationships" xmlns:p="http://schemas.openxmlformats.org/presentationml/2006/main" preserve="1" userDrawn="1" showMasterSp="0">
   <p:cSld name="Closing">
     <p:bg>
@@ -1749,7 +1833,7 @@
         </p:spPr>
         <p:txBody>
           <a:bodyPr wrap="square" lIns="0" tIns="0" rIns="0" bIns="0" anchor="b" rtlCol="0">
-            <a:noAutofit/>
+            <a:normAutofit/>
           </a:bodyPr>
           <a:lstStyle>
             <a:lvl1pPr marL="0" indent="0">
@@ -1790,7 +1874,7 @@
         </p:spPr>
         <p:txBody>
           <a:bodyPr wrap="square" lIns="0" tIns="0" rIns="0" bIns="0" anchor="t" rtlCol="0">
-            <a:noAutofit/>
+            <a:normAutofit/>
           </a:bodyPr>
           <a:lstStyle>
             <a:lvl1pPr marL="0" indent="0">
@@ -1831,7 +1915,7 @@
         </p:spPr>
         <p:txBody>
           <a:bodyPr wrap="square" lIns="0" tIns="0" rIns="0" bIns="0" anchor="t" rtlCol="0">
-            <a:noAutofit/>
+            <a:normAutofit/>
           </a:bodyPr>
           <a:lstStyle>
             <a:lvl1pPr marL="0" indent="0">
@@ -1900,6 +1984,7 @@
   <p:clrMapOvr>
     <a:masterClrMapping/>
   </p:clrMapOvr>
+  <p:hf ftr="0" sldNum="0" hdr="0" dt="0"/>
 </p:sldLayout>
 </file>
 
@@ -1973,7 +2058,7 @@
         </p:spPr>
         <p:txBody>
           <a:bodyPr wrap="square" lIns="0" tIns="0" rIns="0" bIns="0" anchor="b" rtlCol="0">
-            <a:noAutofit/>
+            <a:normAutofit/>
           </a:bodyPr>
           <a:lstStyle>
             <a:lvl1pPr marL="0" indent="0" algn="r">
@@ -2058,7 +2143,7 @@
         </p:spPr>
         <p:txBody>
           <a:bodyPr wrap="square" lIns="0" tIns="0" rIns="0" bIns="0" anchor="t" rtlCol="0">
-            <a:noAutofit/>
+            <a:normAutofit/>
           </a:bodyPr>
           <a:lstStyle>
             <a:lvl1pPr marL="0" indent="0">
@@ -2083,6 +2168,7 @@
   <p:clrMapOvr>
     <a:masterClrMapping/>
   </p:clrMapOvr>
+  <p:hf ftr="0" sldNum="0" hdr="0" dt="0"/>
 </p:sldLayout>
 </file>
 
@@ -2148,7 +2234,7 @@
         </p:spPr>
         <p:txBody>
           <a:bodyPr wrap="square" lIns="0" tIns="0" rIns="0" bIns="0" anchor="b" rtlCol="0">
-            <a:noAutofit/>
+            <a:normAutofit/>
           </a:bodyPr>
           <a:lstStyle>
             <a:lvl1pPr marL="0" indent="0">
@@ -2218,6 +2304,44 @@
               <a:rPr lang="en-US"/>
               <a:t>Click to add text</a:t>
             </a:r>
+          </a:p>
+        </p:txBody>
+      </p:sp>
+      <p:sp>
+        <p:nvSpPr>
+          <p:cNvPr id="6" name="Footer Placeholder"/>
+          <p:cNvSpPr>
+            <a:spLocks noGrp="1"/>
+          </p:cNvSpPr>
+          <p:nvPr>
+            <p:ph type="ftr" idx="11"/>
+          </p:nvPr>
+        </p:nvSpPr>
+        <p:spPr>
+          <a:xfrm rot="16200000">
+            <a:off x="9745675" y="3429000"/>
+            <a:ext cx="4206240" cy="274320"/>
+          </a:xfrm>
+          <a:prstGeom prst="rect">
+            <a:avLst/>
+          </a:prstGeom>
+        </p:spPr>
+        <p:txBody>
+          <a:bodyPr wrap="square" lIns="0" tIns="0" rIns="0" bIns="0" anchor="ctr" rtlCol="0">
+            <a:noAutofit/>
+          </a:bodyPr>
+          <a:lstStyle>
+            <a:lvl1pPr marL="0" indent="0" algn="ctr">
+              <a:buNone/>
+              <a:defRPr lang="en-US" sz="850" b="1" cap="all" spc="190">
+                <a:solidFill>
+                  <a:srgbClr val="FFFFFF"/>
+                </a:solidFill>
+              </a:defRPr>
+            </a:lvl1pPr>
+          </a:lstStyle>
+          <a:p>
+            <a:endParaRPr lang="en-US"/>
           </a:p>
         </p:txBody>
       </p:sp>
@@ -2291,7 +2415,7 @@
         </p:spPr>
         <p:txBody>
           <a:bodyPr wrap="square" lIns="0" tIns="0" rIns="0" bIns="0" anchor="b" rtlCol="0">
-            <a:noAutofit/>
+            <a:normAutofit/>
           </a:bodyPr>
           <a:lstStyle>
             <a:lvl1pPr marL="0" indent="0">
@@ -2397,6 +2521,44 @@
               <a:rPr lang="en-US"/>
               <a:t>Click to add text</a:t>
             </a:r>
+          </a:p>
+        </p:txBody>
+      </p:sp>
+      <p:sp>
+        <p:nvSpPr>
+          <p:cNvPr id="7" name="Footer Placeholder"/>
+          <p:cNvSpPr>
+            <a:spLocks noGrp="1"/>
+          </p:cNvSpPr>
+          <p:nvPr>
+            <p:ph type="ftr" idx="11"/>
+          </p:nvPr>
+        </p:nvSpPr>
+        <p:spPr>
+          <a:xfrm rot="16200000">
+            <a:off x="9745675" y="3429000"/>
+            <a:ext cx="4206240" cy="274320"/>
+          </a:xfrm>
+          <a:prstGeom prst="rect">
+            <a:avLst/>
+          </a:prstGeom>
+        </p:spPr>
+        <p:txBody>
+          <a:bodyPr wrap="square" lIns="0" tIns="0" rIns="0" bIns="0" anchor="ctr" rtlCol="0">
+            <a:noAutofit/>
+          </a:bodyPr>
+          <a:lstStyle>
+            <a:lvl1pPr marL="0" indent="0" algn="ctr">
+              <a:buNone/>
+              <a:defRPr lang="en-US" sz="850" b="1" cap="all" spc="190">
+                <a:solidFill>
+                  <a:srgbClr val="FFFFFF"/>
+                </a:solidFill>
+              </a:defRPr>
+            </a:lvl1pPr>
+          </a:lstStyle>
+          <a:p>
+            <a:endParaRPr lang="en-US"/>
           </a:p>
         </p:txBody>
       </p:sp>
@@ -2470,7 +2632,7 @@
         </p:spPr>
         <p:txBody>
           <a:bodyPr wrap="square" lIns="0" tIns="0" rIns="0" bIns="0" anchor="b" rtlCol="0">
-            <a:noAutofit/>
+            <a:normAutofit/>
           </a:bodyPr>
           <a:lstStyle>
             <a:lvl1pPr marL="0" indent="0">
@@ -2507,6 +2669,44 @@
           </a:ln>
         </p:spPr>
       </p:cxnSp>
+      <p:sp>
+        <p:nvSpPr>
+          <p:cNvPr id="5" name="Footer Placeholder"/>
+          <p:cNvSpPr>
+            <a:spLocks noGrp="1"/>
+          </p:cNvSpPr>
+          <p:nvPr>
+            <p:ph type="ftr" idx="11"/>
+          </p:nvPr>
+        </p:nvSpPr>
+        <p:spPr>
+          <a:xfrm rot="16200000">
+            <a:off x="9745675" y="3429000"/>
+            <a:ext cx="4206240" cy="274320"/>
+          </a:xfrm>
+          <a:prstGeom prst="rect">
+            <a:avLst/>
+          </a:prstGeom>
+        </p:spPr>
+        <p:txBody>
+          <a:bodyPr wrap="square" lIns="0" tIns="0" rIns="0" bIns="0" anchor="ctr" rtlCol="0">
+            <a:noAutofit/>
+          </a:bodyPr>
+          <a:lstStyle>
+            <a:lvl1pPr marL="0" indent="0" algn="ctr">
+              <a:buNone/>
+              <a:defRPr lang="en-US" sz="850" b="1" cap="all" spc="190">
+                <a:solidFill>
+                  <a:srgbClr val="FFFFFF"/>
+                </a:solidFill>
+              </a:defRPr>
+            </a:lvl1pPr>
+          </a:lstStyle>
+          <a:p>
+            <a:endParaRPr lang="en-US"/>
+          </a:p>
+        </p:txBody>
+      </p:sp>
     </p:spTree>
   </p:cSld>
   <p:clrMapOvr>
@@ -2516,6 +2716,158 @@
 </file>
 
 <file path=ppt/slideLayouts/slideLayout6.xml><?xml version="1.0" encoding="utf-8"?>
+<p:sldLayout xmlns:a="http://schemas.openxmlformats.org/drawingml/2006/main" xmlns:r="http://schemas.openxmlformats.org/officeDocument/2006/relationships" xmlns:p="http://schemas.openxmlformats.org/presentationml/2006/main" preserve="1" userDrawn="1" showMasterSp="0">
+  <p:cSld name="Content (no sidebar)">
+    <p:bg>
+      <p:bgPr>
+        <a:solidFill>
+          <a:srgbClr val="FFFFFF"/>
+        </a:solidFill>
+        <a:effectLst/>
+      </p:bgPr>
+    </p:bg>
+    <p:spTree>
+      <p:nvGrpSpPr>
+        <p:cNvPr id="1" name=""/>
+        <p:cNvGrpSpPr/>
+        <p:nvPr/>
+      </p:nvGrpSpPr>
+      <p:grpSpPr>
+        <a:xfrm>
+          <a:off x="0" y="0"/>
+          <a:ext cx="0" cy="0"/>
+          <a:chOff x="0" y="0"/>
+          <a:chExt cx="0" cy="0"/>
+        </a:xfrm>
+      </p:grpSpPr>
+      <p:pic>
+        <p:nvPicPr>
+          <p:cNvPr id="2" name="Logo" descr="Universitas Airlangga logo"/>
+          <p:cNvPicPr>
+            <a:picLocks noChangeAspect="1"/>
+          </p:cNvPicPr>
+          <p:nvPr userDrawn="1"/>
+        </p:nvPicPr>
+        <p:blipFill>
+          <a:blip r:embed="rId2"/>
+          <a:stretch>
+            <a:fillRect/>
+          </a:stretch>
+        </p:blipFill>
+        <p:spPr>
+          <a:xfrm>
+            <a:off x="9357055" y="256032"/>
+            <a:ext cx="1828800" cy="688562"/>
+          </a:xfrm>
+          <a:prstGeom prst="rect">
+            <a:avLst/>
+          </a:prstGeom>
+        </p:spPr>
+      </p:pic>
+      <p:sp>
+        <p:nvSpPr>
+          <p:cNvPr id="3" name="Title"/>
+          <p:cNvSpPr>
+            <a:spLocks noGrp="1"/>
+          </p:cNvSpPr>
+          <p:nvPr>
+            <p:ph type="title" hasCustomPrompt="1"/>
+          </p:nvPr>
+        </p:nvSpPr>
+        <p:spPr>
+          <a:xfrm>
+            <a:off x="548640" y="274320"/>
+            <a:ext cx="8503920" cy="841248"/>
+          </a:xfrm>
+          <a:prstGeom prst="rect">
+            <a:avLst/>
+          </a:prstGeom>
+        </p:spPr>
+        <p:txBody>
+          <a:bodyPr wrap="square" lIns="0" tIns="0" rIns="0" bIns="0" anchor="b" rtlCol="0">
+            <a:normAutofit/>
+          </a:bodyPr>
+          <a:lstStyle>
+            <a:lvl1pPr marL="0" indent="0">
+              <a:buNone/>
+              <a:defRPr lang="en-US"/>
+            </a:lvl1pPr>
+          </a:lstStyle>
+          <a:p>
+            <a:r>
+              <a:rPr lang="en-US"/>
+              <a:t>Click to edit title</a:t>
+            </a:r>
+          </a:p>
+        </p:txBody>
+      </p:sp>
+      <p:cxnSp>
+        <p:nvCxnSpPr>
+          <p:cNvPr id="4" name="Title rule"/>
+          <p:cNvCxnSpPr/>
+          <p:nvPr userDrawn="1"/>
+        </p:nvCxnSpPr>
+        <p:spPr>
+          <a:xfrm>
+            <a:off x="548640" y="1188720"/>
+            <a:ext cx="10545775" cy="0"/>
+          </a:xfrm>
+          <a:prstGeom prst="line">
+            <a:avLst/>
+          </a:prstGeom>
+          <a:ln w="28575">
+            <a:solidFill>
+              <a:srgbClr val="FFCB05"/>
+            </a:solidFill>
+          </a:ln>
+        </p:spPr>
+      </p:cxnSp>
+      <p:sp>
+        <p:nvSpPr>
+          <p:cNvPr id="5" name="Content"/>
+          <p:cNvSpPr>
+            <a:spLocks noGrp="1"/>
+          </p:cNvSpPr>
+          <p:nvPr>
+            <p:ph idx="1" hasCustomPrompt="1"/>
+          </p:nvPr>
+        </p:nvSpPr>
+        <p:spPr>
+          <a:xfrm>
+            <a:off x="548640" y="1463040"/>
+            <a:ext cx="10545775" cy="4892040"/>
+          </a:xfrm>
+          <a:prstGeom prst="rect">
+            <a:avLst/>
+          </a:prstGeom>
+        </p:spPr>
+        <p:txBody>
+          <a:bodyPr wrap="square" lIns="0" tIns="0" rIns="0" bIns="0" anchor="t" rtlCol="0">
+            <a:normAutofit/>
+          </a:bodyPr>
+          <a:lstStyle>
+            <a:lvl1pPr>
+              <a:defRPr lang="en-US"/>
+            </a:lvl1pPr>
+          </a:lstStyle>
+          <a:p>
+            <a:r>
+              <a:rPr lang="en-US"/>
+              <a:t>Click to add text</a:t>
+            </a:r>
+          </a:p>
+        </p:txBody>
+      </p:sp>
+    </p:spTree>
+  </p:cSld>
+  <p:clrMapOvr>
+    <a:masterClrMapping/>
+  </p:clrMapOvr>
+  <p:hf ftr="0" sldNum="0" hdr="0" dt="0"/>
+</p:sldLayout>
+</file>
+
+<file path=ppt/slideLayouts/slideLayout7.xml><?xml version="1.0" encoding="utf-8"?>
 <p:sldLayout xmlns:a="http://schemas.openxmlformats.org/drawingml/2006/main" xmlns:r="http://schemas.openxmlformats.org/officeDocument/2006/relationships" xmlns:p="http://schemas.openxmlformats.org/presentationml/2006/main" preserve="1" userDrawn="1" showMasterSp="0">
   <p:cSld name="Agenda">
     <p:bg>
@@ -2600,582 +2952,67 @@
       </p:sp>
       <p:sp>
         <p:nvSpPr>
-          <p:cNvPr id="4" name="Number 1"/>
-          <p:cNvSpPr txBox="1"/>
-          <p:nvPr userDrawn="1"/>
+          <p:cNvPr id="4" name="Items"/>
+          <p:cNvSpPr>
+            <a:spLocks noGrp="1"/>
+          </p:cNvSpPr>
+          <p:nvPr>
+            <p:ph type="body" idx="1" hasCustomPrompt="1"/>
+          </p:nvPr>
         </p:nvSpPr>
         <p:spPr>
           <a:xfrm>
             <a:off x="1706837" y="822960"/>
-            <a:ext cx="1188720" cy="1042416"/>
-          </a:xfrm>
-          <a:prstGeom prst="rect">
-            <a:avLst/>
-          </a:prstGeom>
-          <a:noFill/>
+            <a:ext cx="9509522" cy="5212080"/>
+          </a:xfrm>
+          <a:prstGeom prst="rect">
+            <a:avLst/>
+          </a:prstGeom>
         </p:spPr>
         <p:txBody>
           <a:bodyPr wrap="square" lIns="0" tIns="0" rIns="0" bIns="0" anchor="ctr" rtlCol="0">
-            <a:noAutofit/>
-          </a:bodyPr>
-          <a:lstStyle/>
-          <a:p>
-            <a:r>
-              <a:rPr lang="en-US" sz="4000" b="1">
-                <a:solidFill>
-                  <a:srgbClr val="14497F"/>
-                </a:solidFill>
-              </a:rPr>
-              <a:t>01</a:t>
-            </a:r>
-          </a:p>
-        </p:txBody>
-      </p:sp>
-      <p:sp>
-        <p:nvSpPr>
-          <p:cNvPr id="5" name="Item 1"/>
-          <p:cNvSpPr>
-            <a:spLocks noGrp="1"/>
-          </p:cNvSpPr>
-          <p:nvPr>
-            <p:ph type="body" idx="20" hasCustomPrompt="1"/>
-          </p:nvPr>
-        </p:nvSpPr>
-        <p:spPr>
-          <a:xfrm>
-            <a:off x="2941277" y="822960"/>
-            <a:ext cx="7863602" cy="1042416"/>
-          </a:xfrm>
-          <a:prstGeom prst="rect">
-            <a:avLst/>
-          </a:prstGeom>
-        </p:spPr>
-        <p:txBody>
-          <a:bodyPr wrap="square" lIns="0" tIns="0" rIns="0" bIns="0" anchor="ctr" rtlCol="0">
-            <a:noAutofit/>
+            <a:normAutofit/>
           </a:bodyPr>
           <a:lstStyle>
-            <a:lvl1pPr marL="0" indent="0">
-              <a:buNone/>
-              <a:defRPr lang="en-US" sz="2000">
+            <a:lvl1pPr marL="960120" indent="-960120">
+              <a:lnSpc>
+                <a:spcPct val="145000"/>
+              </a:lnSpc>
+              <a:spcAft>
+                <a:spcPts val="1600"/>
+              </a:spcAft>
+              <a:buClr>
+                <a:srgbClr val="14497F"/>
+              </a:buClr>
+              <a:buSzPct val="205000"/>
+              <a:buFont typeface="Segoe UI"/>
+              <a:buAutoNum type="arabicPlain"/>
+              <a:defRPr lang="en-US" sz="2000" b="1">
                 <a:solidFill>
                   <a:srgbClr val="333333"/>
                 </a:solidFill>
-                <a:latin typeface="Segoe UI Semibold"/>
+                <a:latin typeface="Segoe UI"/>
               </a:defRPr>
             </a:lvl1pPr>
           </a:lstStyle>
           <a:p>
             <a:r>
               <a:rPr lang="en-US"/>
-              <a:t>Agenda item 1</a:t>
-            </a:r>
-          </a:p>
-        </p:txBody>
-      </p:sp>
-      <p:sp>
-        <p:nvSpPr>
-          <p:cNvPr id="6" name="Dot 1"/>
-          <p:cNvSpPr/>
-          <p:nvPr userDrawn="1"/>
-        </p:nvSpPr>
-        <p:spPr>
-          <a:xfrm>
-            <a:off x="11134064" y="1303020"/>
-            <a:ext cx="82296" cy="82296"/>
-          </a:xfrm>
-          <a:prstGeom prst="ellipse">
-            <a:avLst/>
-          </a:prstGeom>
-          <a:solidFill>
-            <a:srgbClr val="FFCB05"/>
-          </a:solidFill>
-          <a:ln>
-            <a:noFill/>
-          </a:ln>
-        </p:spPr>
-      </p:sp>
-      <p:cxnSp>
-        <p:nvCxnSpPr>
-          <p:cNvPr id="7" name="Separator 1"/>
-          <p:cNvCxnSpPr/>
-          <p:nvPr userDrawn="1"/>
-        </p:nvCxnSpPr>
-        <p:spPr>
-          <a:xfrm>
-            <a:off x="1706837" y="1865376"/>
-            <a:ext cx="9509522" cy="0"/>
-          </a:xfrm>
-          <a:prstGeom prst="line">
-            <a:avLst/>
-          </a:prstGeom>
-          <a:ln w="9525">
-            <a:solidFill>
-              <a:srgbClr val="E8E8E8"/>
-            </a:solidFill>
-          </a:ln>
-        </p:spPr>
-      </p:cxnSp>
-      <p:sp>
-        <p:nvSpPr>
-          <p:cNvPr id="8" name="Number 2"/>
-          <p:cNvSpPr txBox="1"/>
-          <p:nvPr userDrawn="1"/>
-        </p:nvSpPr>
-        <p:spPr>
-          <a:xfrm>
-            <a:off x="1706837" y="1865376"/>
-            <a:ext cx="1188720" cy="1042416"/>
-          </a:xfrm>
-          <a:prstGeom prst="rect">
-            <a:avLst/>
-          </a:prstGeom>
-          <a:noFill/>
-        </p:spPr>
-        <p:txBody>
-          <a:bodyPr wrap="square" lIns="0" tIns="0" rIns="0" bIns="0" anchor="ctr" rtlCol="0">
-            <a:noAutofit/>
-          </a:bodyPr>
-          <a:lstStyle/>
-          <a:p>
-            <a:r>
-              <a:rPr lang="en-US" sz="4000" b="1">
-                <a:solidFill>
-                  <a:srgbClr val="14497F"/>
-                </a:solidFill>
-              </a:rPr>
-              <a:t>02</a:t>
-            </a:r>
-          </a:p>
-        </p:txBody>
-      </p:sp>
-      <p:sp>
-        <p:nvSpPr>
-          <p:cNvPr id="9" name="Item 2"/>
-          <p:cNvSpPr>
-            <a:spLocks noGrp="1"/>
-          </p:cNvSpPr>
-          <p:nvPr>
-            <p:ph type="body" idx="21" hasCustomPrompt="1"/>
-          </p:nvPr>
-        </p:nvSpPr>
-        <p:spPr>
-          <a:xfrm>
-            <a:off x="2941277" y="1865376"/>
-            <a:ext cx="7863602" cy="1042416"/>
-          </a:xfrm>
-          <a:prstGeom prst="rect">
-            <a:avLst/>
-          </a:prstGeom>
-        </p:spPr>
-        <p:txBody>
-          <a:bodyPr wrap="square" lIns="0" tIns="0" rIns="0" bIns="0" anchor="ctr" rtlCol="0">
-            <a:noAutofit/>
-          </a:bodyPr>
-          <a:lstStyle>
-            <a:lvl1pPr marL="0" indent="0">
-              <a:buNone/>
-              <a:defRPr lang="en-US" sz="2000">
-                <a:solidFill>
-                  <a:srgbClr val="333333"/>
-                </a:solidFill>
-                <a:latin typeface="Segoe UI Semibold"/>
-              </a:defRPr>
-            </a:lvl1pPr>
-          </a:lstStyle>
-          <a:p>
-            <a:r>
-              <a:rPr lang="en-US"/>
-              <a:t>Agenda item 2</a:t>
-            </a:r>
-          </a:p>
-        </p:txBody>
-      </p:sp>
-      <p:sp>
-        <p:nvSpPr>
-          <p:cNvPr id="10" name="Dot 2"/>
-          <p:cNvSpPr/>
-          <p:nvPr userDrawn="1"/>
-        </p:nvSpPr>
-        <p:spPr>
-          <a:xfrm>
-            <a:off x="11134064" y="2345436"/>
-            <a:ext cx="82296" cy="82296"/>
-          </a:xfrm>
-          <a:prstGeom prst="ellipse">
-            <a:avLst/>
-          </a:prstGeom>
-          <a:solidFill>
-            <a:srgbClr val="FFCB05"/>
-          </a:solidFill>
-          <a:ln>
-            <a:noFill/>
-          </a:ln>
-        </p:spPr>
-      </p:sp>
-      <p:cxnSp>
-        <p:nvCxnSpPr>
-          <p:cNvPr id="11" name="Separator 2"/>
-          <p:cNvCxnSpPr/>
-          <p:nvPr userDrawn="1"/>
-        </p:nvCxnSpPr>
-        <p:spPr>
-          <a:xfrm>
-            <a:off x="1706837" y="2907792"/>
-            <a:ext cx="9509522" cy="0"/>
-          </a:xfrm>
-          <a:prstGeom prst="line">
-            <a:avLst/>
-          </a:prstGeom>
-          <a:ln w="9525">
-            <a:solidFill>
-              <a:srgbClr val="E8E8E8"/>
-            </a:solidFill>
-          </a:ln>
-        </p:spPr>
-      </p:cxnSp>
-      <p:sp>
-        <p:nvSpPr>
-          <p:cNvPr id="12" name="Number 3"/>
-          <p:cNvSpPr txBox="1"/>
-          <p:nvPr userDrawn="1"/>
-        </p:nvSpPr>
-        <p:spPr>
-          <a:xfrm>
-            <a:off x="1706837" y="2907792"/>
-            <a:ext cx="1188720" cy="1042416"/>
-          </a:xfrm>
-          <a:prstGeom prst="rect">
-            <a:avLst/>
-          </a:prstGeom>
-          <a:noFill/>
-        </p:spPr>
-        <p:txBody>
-          <a:bodyPr wrap="square" lIns="0" tIns="0" rIns="0" bIns="0" anchor="ctr" rtlCol="0">
-            <a:noAutofit/>
-          </a:bodyPr>
-          <a:lstStyle/>
-          <a:p>
-            <a:r>
-              <a:rPr lang="en-US" sz="4000" b="1">
-                <a:solidFill>
-                  <a:srgbClr val="14497F"/>
-                </a:solidFill>
-              </a:rPr>
-              <a:t>03</a:t>
-            </a:r>
-          </a:p>
-        </p:txBody>
-      </p:sp>
-      <p:sp>
-        <p:nvSpPr>
-          <p:cNvPr id="13" name="Item 3"/>
-          <p:cNvSpPr>
-            <a:spLocks noGrp="1"/>
-          </p:cNvSpPr>
-          <p:nvPr>
-            <p:ph type="body" idx="22" hasCustomPrompt="1"/>
-          </p:nvPr>
-        </p:nvSpPr>
-        <p:spPr>
-          <a:xfrm>
-            <a:off x="2941277" y="2907792"/>
-            <a:ext cx="7863602" cy="1042416"/>
-          </a:xfrm>
-          <a:prstGeom prst="rect">
-            <a:avLst/>
-          </a:prstGeom>
-        </p:spPr>
-        <p:txBody>
-          <a:bodyPr wrap="square" lIns="0" tIns="0" rIns="0" bIns="0" anchor="ctr" rtlCol="0">
-            <a:noAutofit/>
-          </a:bodyPr>
-          <a:lstStyle>
-            <a:lvl1pPr marL="0" indent="0">
-              <a:buNone/>
-              <a:defRPr lang="en-US" sz="2000">
-                <a:solidFill>
-                  <a:srgbClr val="333333"/>
-                </a:solidFill>
-                <a:latin typeface="Segoe UI Semibold"/>
-              </a:defRPr>
-            </a:lvl1pPr>
-          </a:lstStyle>
-          <a:p>
-            <a:r>
-              <a:rPr lang="en-US"/>
-              <a:t>Agenda item 3</a:t>
-            </a:r>
-          </a:p>
-        </p:txBody>
-      </p:sp>
-      <p:sp>
-        <p:nvSpPr>
-          <p:cNvPr id="14" name="Dot 3"/>
-          <p:cNvSpPr/>
-          <p:nvPr userDrawn="1"/>
-        </p:nvSpPr>
-        <p:spPr>
-          <a:xfrm>
-            <a:off x="11134064" y="3387852"/>
-            <a:ext cx="82296" cy="82296"/>
-          </a:xfrm>
-          <a:prstGeom prst="ellipse">
-            <a:avLst/>
-          </a:prstGeom>
-          <a:solidFill>
-            <a:srgbClr val="FFCB05"/>
-          </a:solidFill>
-          <a:ln>
-            <a:noFill/>
-          </a:ln>
-        </p:spPr>
-      </p:sp>
-      <p:cxnSp>
-        <p:nvCxnSpPr>
-          <p:cNvPr id="15" name="Separator 3"/>
-          <p:cNvCxnSpPr/>
-          <p:nvPr userDrawn="1"/>
-        </p:nvCxnSpPr>
-        <p:spPr>
-          <a:xfrm>
-            <a:off x="1706837" y="3950208"/>
-            <a:ext cx="9509522" cy="0"/>
-          </a:xfrm>
-          <a:prstGeom prst="line">
-            <a:avLst/>
-          </a:prstGeom>
-          <a:ln w="9525">
-            <a:solidFill>
-              <a:srgbClr val="E8E8E8"/>
-            </a:solidFill>
-          </a:ln>
-        </p:spPr>
-      </p:cxnSp>
-      <p:sp>
-        <p:nvSpPr>
-          <p:cNvPr id="16" name="Number 4"/>
-          <p:cNvSpPr txBox="1"/>
-          <p:nvPr userDrawn="1"/>
-        </p:nvSpPr>
-        <p:spPr>
-          <a:xfrm>
-            <a:off x="1706837" y="3950208"/>
-            <a:ext cx="1188720" cy="1042416"/>
-          </a:xfrm>
-          <a:prstGeom prst="rect">
-            <a:avLst/>
-          </a:prstGeom>
-          <a:noFill/>
-        </p:spPr>
-        <p:txBody>
-          <a:bodyPr wrap="square" lIns="0" tIns="0" rIns="0" bIns="0" anchor="ctr" rtlCol="0">
-            <a:noAutofit/>
-          </a:bodyPr>
-          <a:lstStyle/>
-          <a:p>
-            <a:r>
-              <a:rPr lang="en-US" sz="4000" b="1">
-                <a:solidFill>
-                  <a:srgbClr val="14497F"/>
-                </a:solidFill>
-              </a:rPr>
-              <a:t>04</a:t>
-            </a:r>
-          </a:p>
-        </p:txBody>
-      </p:sp>
-      <p:sp>
-        <p:nvSpPr>
-          <p:cNvPr id="17" name="Item 4"/>
-          <p:cNvSpPr>
-            <a:spLocks noGrp="1"/>
-          </p:cNvSpPr>
-          <p:nvPr>
-            <p:ph type="body" idx="23" hasCustomPrompt="1"/>
-          </p:nvPr>
-        </p:nvSpPr>
-        <p:spPr>
-          <a:xfrm>
-            <a:off x="2941277" y="3950208"/>
-            <a:ext cx="7863602" cy="1042416"/>
-          </a:xfrm>
-          <a:prstGeom prst="rect">
-            <a:avLst/>
-          </a:prstGeom>
-        </p:spPr>
-        <p:txBody>
-          <a:bodyPr wrap="square" lIns="0" tIns="0" rIns="0" bIns="0" anchor="ctr" rtlCol="0">
-            <a:noAutofit/>
-          </a:bodyPr>
-          <a:lstStyle>
-            <a:lvl1pPr marL="0" indent="0">
-              <a:buNone/>
-              <a:defRPr lang="en-US" sz="2000">
-                <a:solidFill>
-                  <a:srgbClr val="333333"/>
-                </a:solidFill>
-                <a:latin typeface="Segoe UI Semibold"/>
-              </a:defRPr>
-            </a:lvl1pPr>
-          </a:lstStyle>
-          <a:p>
-            <a:r>
-              <a:rPr lang="en-US"/>
-              <a:t>Agenda item 4</a:t>
-            </a:r>
-          </a:p>
-        </p:txBody>
-      </p:sp>
-      <p:sp>
-        <p:nvSpPr>
-          <p:cNvPr id="18" name="Dot 4"/>
-          <p:cNvSpPr/>
-          <p:nvPr userDrawn="1"/>
-        </p:nvSpPr>
-        <p:spPr>
-          <a:xfrm>
-            <a:off x="11134064" y="4430268"/>
-            <a:ext cx="82296" cy="82296"/>
-          </a:xfrm>
-          <a:prstGeom prst="ellipse">
-            <a:avLst/>
-          </a:prstGeom>
-          <a:solidFill>
-            <a:srgbClr val="FFCB05"/>
-          </a:solidFill>
-          <a:ln>
-            <a:noFill/>
-          </a:ln>
-        </p:spPr>
-      </p:sp>
-      <p:cxnSp>
-        <p:nvCxnSpPr>
-          <p:cNvPr id="19" name="Separator 4"/>
-          <p:cNvCxnSpPr/>
-          <p:nvPr userDrawn="1"/>
-        </p:nvCxnSpPr>
-        <p:spPr>
-          <a:xfrm>
-            <a:off x="1706837" y="4992624"/>
-            <a:ext cx="9509522" cy="0"/>
-          </a:xfrm>
-          <a:prstGeom prst="line">
-            <a:avLst/>
-          </a:prstGeom>
-          <a:ln w="9525">
-            <a:solidFill>
-              <a:srgbClr val="E8E8E8"/>
-            </a:solidFill>
-          </a:ln>
-        </p:spPr>
-      </p:cxnSp>
-      <p:sp>
-        <p:nvSpPr>
-          <p:cNvPr id="20" name="Number 5"/>
-          <p:cNvSpPr txBox="1"/>
-          <p:nvPr userDrawn="1"/>
-        </p:nvSpPr>
-        <p:spPr>
-          <a:xfrm>
-            <a:off x="1706837" y="4992624"/>
-            <a:ext cx="1188720" cy="1042416"/>
-          </a:xfrm>
-          <a:prstGeom prst="rect">
-            <a:avLst/>
-          </a:prstGeom>
-          <a:noFill/>
-        </p:spPr>
-        <p:txBody>
-          <a:bodyPr wrap="square" lIns="0" tIns="0" rIns="0" bIns="0" anchor="ctr" rtlCol="0">
-            <a:noAutofit/>
-          </a:bodyPr>
-          <a:lstStyle/>
-          <a:p>
-            <a:r>
-              <a:rPr lang="en-US" sz="4000" b="1">
-                <a:solidFill>
-                  <a:srgbClr val="14497F"/>
-                </a:solidFill>
-              </a:rPr>
-              <a:t>05</a:t>
-            </a:r>
-          </a:p>
-        </p:txBody>
-      </p:sp>
-      <p:sp>
-        <p:nvSpPr>
-          <p:cNvPr id="21" name="Item 5"/>
-          <p:cNvSpPr>
-            <a:spLocks noGrp="1"/>
-          </p:cNvSpPr>
-          <p:nvPr>
-            <p:ph type="body" idx="24" hasCustomPrompt="1"/>
-          </p:nvPr>
-        </p:nvSpPr>
-        <p:spPr>
-          <a:xfrm>
-            <a:off x="2941277" y="4992624"/>
-            <a:ext cx="7863602" cy="1042416"/>
-          </a:xfrm>
-          <a:prstGeom prst="rect">
-            <a:avLst/>
-          </a:prstGeom>
-        </p:spPr>
-        <p:txBody>
-          <a:bodyPr wrap="square" lIns="0" tIns="0" rIns="0" bIns="0" anchor="ctr" rtlCol="0">
-            <a:noAutofit/>
-          </a:bodyPr>
-          <a:lstStyle>
-            <a:lvl1pPr marL="0" indent="0">
-              <a:buNone/>
-              <a:defRPr lang="en-US" sz="2000">
-                <a:solidFill>
-                  <a:srgbClr val="333333"/>
-                </a:solidFill>
-                <a:latin typeface="Segoe UI Semibold"/>
-              </a:defRPr>
-            </a:lvl1pPr>
-          </a:lstStyle>
-          <a:p>
-            <a:r>
-              <a:rPr lang="en-US"/>
-              <a:t>Agenda item 5</a:t>
-            </a:r>
-          </a:p>
-        </p:txBody>
-      </p:sp>
-      <p:sp>
-        <p:nvSpPr>
-          <p:cNvPr id="22" name="Dot 5"/>
-          <p:cNvSpPr/>
-          <p:nvPr userDrawn="1"/>
-        </p:nvSpPr>
-        <p:spPr>
-          <a:xfrm>
-            <a:off x="11134064" y="5472684"/>
-            <a:ext cx="82296" cy="82296"/>
-          </a:xfrm>
-          <a:prstGeom prst="ellipse">
-            <a:avLst/>
-          </a:prstGeom>
-          <a:solidFill>
-            <a:srgbClr val="FFCB05"/>
-          </a:solidFill>
-          <a:ln>
-            <a:noFill/>
-          </a:ln>
-        </p:spPr>
+              <a:t>Click to add agenda items</a:t>
+            </a:r>
+          </a:p>
+        </p:txBody>
       </p:sp>
     </p:spTree>
   </p:cSld>
   <p:clrMapOvr>
     <a:masterClrMapping/>
   </p:clrMapOvr>
+  <p:hf ftr="0" sldNum="0" hdr="0" dt="0"/>
 </p:sldLayout>
 </file>
 
-<file path=ppt/slideLayouts/slideLayout7.xml><?xml version="1.0" encoding="utf-8"?>
+<file path=ppt/slideLayouts/slideLayout8.xml><?xml version="1.0" encoding="utf-8"?>
 <p:sldLayout xmlns:a="http://schemas.openxmlformats.org/drawingml/2006/main" xmlns:r="http://schemas.openxmlformats.org/officeDocument/2006/relationships" xmlns:p="http://schemas.openxmlformats.org/presentationml/2006/main" preserve="1" userDrawn="1">
   <p:cSld name="Text + Image">
     <p:spTree>
@@ -3254,7 +3091,7 @@
         </p:spPr>
         <p:txBody>
           <a:bodyPr wrap="square" lIns="0" tIns="0" rIns="0" bIns="0" anchor="b" rtlCol="0">
-            <a:noAutofit/>
+            <a:normAutofit/>
           </a:bodyPr>
           <a:lstStyle>
             <a:lvl1pPr marL="0" indent="0">
@@ -3306,6 +3143,44 @@
           </a:p>
         </p:txBody>
       </p:sp>
+      <p:sp>
+        <p:nvSpPr>
+          <p:cNvPr id="5" name="Footer Placeholder"/>
+          <p:cNvSpPr>
+            <a:spLocks noGrp="1"/>
+          </p:cNvSpPr>
+          <p:nvPr>
+            <p:ph type="ftr" idx="11"/>
+          </p:nvPr>
+        </p:nvSpPr>
+        <p:spPr>
+          <a:xfrm rot="16200000">
+            <a:off x="9745675" y="3429000"/>
+            <a:ext cx="4206240" cy="274320"/>
+          </a:xfrm>
+          <a:prstGeom prst="rect">
+            <a:avLst/>
+          </a:prstGeom>
+        </p:spPr>
+        <p:txBody>
+          <a:bodyPr wrap="square" lIns="0" tIns="0" rIns="0" bIns="0" anchor="ctr" rtlCol="0">
+            <a:noAutofit/>
+          </a:bodyPr>
+          <a:lstStyle>
+            <a:lvl1pPr marL="0" indent="0" algn="ctr">
+              <a:buNone/>
+              <a:defRPr lang="en-US" sz="850" b="1" cap="all" spc="190">
+                <a:solidFill>
+                  <a:srgbClr val="FFFFFF"/>
+                </a:solidFill>
+              </a:defRPr>
+            </a:lvl1pPr>
+          </a:lstStyle>
+          <a:p>
+            <a:endParaRPr lang="en-US"/>
+          </a:p>
+        </p:txBody>
+      </p:sp>
     </p:spTree>
   </p:cSld>
   <p:clrMapOvr>
@@ -3314,7 +3189,7 @@
 </p:sldLayout>
 </file>
 
-<file path=ppt/slideLayouts/slideLayout8.xml><?xml version="1.0" encoding="utf-8"?>
+<file path=ppt/slideLayouts/slideLayout9.xml><?xml version="1.0" encoding="utf-8"?>
 <p:sldLayout xmlns:a="http://schemas.openxmlformats.org/drawingml/2006/main" xmlns:r="http://schemas.openxmlformats.org/officeDocument/2006/relationships" xmlns:p="http://schemas.openxmlformats.org/presentationml/2006/main" preserve="1" userDrawn="1">
   <p:cSld name="Image + Text">
     <p:spTree>
@@ -3393,7 +3268,7 @@
         </p:spPr>
         <p:txBody>
           <a:bodyPr wrap="square" lIns="0" tIns="0" rIns="0" bIns="0" anchor="b" rtlCol="0">
-            <a:noAutofit/>
+            <a:normAutofit/>
           </a:bodyPr>
           <a:lstStyle>
             <a:lvl1pPr marL="0" indent="0">
@@ -3449,240 +3324,41 @@
           </a:p>
         </p:txBody>
       </p:sp>
-    </p:spTree>
-  </p:cSld>
-  <p:clrMapOvr>
-    <a:masterClrMapping/>
-  </p:clrMapOvr>
-</p:sldLayout>
-</file>
-
-<file path=ppt/slideLayouts/slideLayout9.xml><?xml version="1.0" encoding="utf-8"?>
-<p:sldLayout xmlns:a="http://schemas.openxmlformats.org/drawingml/2006/main" xmlns:r="http://schemas.openxmlformats.org/officeDocument/2006/relationships" xmlns:p="http://schemas.openxmlformats.org/presentationml/2006/main" preserve="1" userDrawn="1">
-  <p:cSld name="Text + Shaded Box">
-    <p:spTree>
-      <p:nvGrpSpPr>
-        <p:cNvPr id="1" name=""/>
-        <p:cNvGrpSpPr/>
-        <p:nvPr/>
-      </p:nvGrpSpPr>
-      <p:grpSpPr>
-        <a:xfrm>
-          <a:off x="0" y="0"/>
-          <a:ext cx="0" cy="0"/>
-          <a:chOff x="0" y="0"/>
-          <a:chExt cx="0" cy="0"/>
-        </a:xfrm>
-      </p:grpSpPr>
-      <p:pic>
-        <p:nvPicPr>
-          <p:cNvPr id="2" name="Logo" descr="Universitas Airlangga logo"/>
-          <p:cNvPicPr>
-            <a:picLocks noChangeAspect="1"/>
-          </p:cNvPicPr>
-          <p:nvPr userDrawn="1"/>
-        </p:nvPicPr>
-        <p:blipFill>
-          <a:blip r:embed="rId2"/>
-          <a:stretch>
-            <a:fillRect/>
-          </a:stretch>
-        </p:blipFill>
-        <p:spPr>
-          <a:xfrm>
-            <a:off x="9357055" y="256032"/>
-            <a:ext cx="1828800" cy="688562"/>
-          </a:xfrm>
-          <a:prstGeom prst="rect">
-            <a:avLst/>
-          </a:prstGeom>
-        </p:spPr>
-      </p:pic>
-      <p:sp>
-        <p:nvSpPr>
-          <p:cNvPr id="3" name="Title"/>
-          <p:cNvSpPr>
-            <a:spLocks noGrp="1"/>
-          </p:cNvSpPr>
-          <p:nvPr>
-            <p:ph type="title" hasCustomPrompt="1"/>
-          </p:nvPr>
-        </p:nvSpPr>
-        <p:spPr>
-          <a:xfrm>
-            <a:off x="548640" y="274320"/>
-            <a:ext cx="8503920" cy="841248"/>
-          </a:xfrm>
-          <a:prstGeom prst="rect">
-            <a:avLst/>
-          </a:prstGeom>
-        </p:spPr>
-        <p:txBody>
-          <a:bodyPr wrap="square" lIns="0" tIns="0" rIns="0" bIns="0" anchor="b" rtlCol="0">
+      <p:sp>
+        <p:nvSpPr>
+          <p:cNvPr id="5" name="Footer Placeholder"/>
+          <p:cNvSpPr>
+            <a:spLocks noGrp="1"/>
+          </p:cNvSpPr>
+          <p:nvPr>
+            <p:ph type="ftr" idx="11"/>
+          </p:nvPr>
+        </p:nvSpPr>
+        <p:spPr>
+          <a:xfrm rot="16200000">
+            <a:off x="9745675" y="3429000"/>
+            <a:ext cx="4206240" cy="274320"/>
+          </a:xfrm>
+          <a:prstGeom prst="rect">
+            <a:avLst/>
+          </a:prstGeom>
+        </p:spPr>
+        <p:txBody>
+          <a:bodyPr wrap="square" lIns="0" tIns="0" rIns="0" bIns="0" anchor="ctr" rtlCol="0">
             <a:noAutofit/>
           </a:bodyPr>
           <a:lstStyle>
-            <a:lvl1pPr marL="0" indent="0">
+            <a:lvl1pPr marL="0" indent="0" algn="ctr">
               <a:buNone/>
-              <a:defRPr lang="en-US"/>
-            </a:lvl1pPr>
-          </a:lstStyle>
-          <a:p>
-            <a:r>
-              <a:rPr lang="en-US"/>
-              <a:t>Click to edit title</a:t>
-            </a:r>
-          </a:p>
-        </p:txBody>
-      </p:sp>
-      <p:cxnSp>
-        <p:nvCxnSpPr>
-          <p:cNvPr id="4" name="Title rule"/>
-          <p:cNvCxnSpPr/>
-          <p:nvPr userDrawn="1"/>
-        </p:nvCxnSpPr>
-        <p:spPr>
-          <a:xfrm>
-            <a:off x="548640" y="1188720"/>
-            <a:ext cx="10545775" cy="0"/>
-          </a:xfrm>
-          <a:prstGeom prst="line">
-            <a:avLst/>
-          </a:prstGeom>
-          <a:ln w="28575">
-            <a:solidFill>
-              <a:srgbClr val="FFCB05"/>
-            </a:solidFill>
-          </a:ln>
-        </p:spPr>
-      </p:cxnSp>
-      <p:sp>
-        <p:nvSpPr>
-          <p:cNvPr id="5" name="Lead"/>
-          <p:cNvSpPr>
-            <a:spLocks noGrp="1"/>
-          </p:cNvSpPr>
-          <p:nvPr>
-            <p:ph type="body" idx="10" hasCustomPrompt="1"/>
-          </p:nvPr>
-        </p:nvSpPr>
-        <p:spPr>
-          <a:xfrm>
-            <a:off x="548640" y="1481328"/>
-            <a:ext cx="10545775" cy="1005840"/>
-          </a:xfrm>
-          <a:prstGeom prst="rect">
-            <a:avLst/>
-          </a:prstGeom>
-        </p:spPr>
-        <p:txBody>
-          <a:bodyPr wrap="square" lIns="0" tIns="0" rIns="0" bIns="0" anchor="t" rtlCol="0">
-            <a:noAutofit/>
-          </a:bodyPr>
-          <a:lstStyle>
-            <a:lvl1pPr marL="0" indent="0">
-              <a:lnSpc>
-                <a:spcPct val="115000"/>
-              </a:lnSpc>
-              <a:buNone/>
-              <a:defRPr lang="en-US" sz="2200">
-                <a:latin typeface="Segoe UI Light"/>
+              <a:defRPr lang="en-US" sz="850" b="1" cap="all" spc="190">
+                <a:solidFill>
+                  <a:srgbClr val="FFFFFF"/>
+                </a:solidFill>
               </a:defRPr>
             </a:lvl1pPr>
           </a:lstStyle>
           <a:p>
-            <a:r>
-              <a:rPr lang="en-US"/>
-              <a:t>Introductory sentence</a:t>
-            </a:r>
-          </a:p>
-        </p:txBody>
-      </p:sp>
-      <p:sp>
-        <p:nvSpPr>
-          <p:cNvPr id="6" name="Box accent"/>
-          <p:cNvSpPr/>
-          <p:nvPr userDrawn="1"/>
-        </p:nvSpPr>
-        <p:spPr>
-          <a:xfrm>
-            <a:off x="548640" y="2697480"/>
-            <a:ext cx="10545775" cy="3520440"/>
-          </a:xfrm>
-          <a:prstGeom prst="roundRect">
-            <a:avLst>
-              <a:gd name="adj" fmla="val 2500"/>
-            </a:avLst>
-          </a:prstGeom>
-          <a:solidFill>
-            <a:srgbClr val="FFCB05"/>
-          </a:solidFill>
-          <a:ln>
-            <a:noFill/>
-          </a:ln>
-        </p:spPr>
-      </p:sp>
-      <p:sp>
-        <p:nvSpPr>
-          <p:cNvPr id="7" name="Box"/>
-          <p:cNvSpPr/>
-          <p:nvPr userDrawn="1"/>
-        </p:nvSpPr>
-        <p:spPr>
-          <a:xfrm>
-            <a:off x="621792" y="2697480"/>
-            <a:ext cx="10472623" cy="3520440"/>
-          </a:xfrm>
-          <a:prstGeom prst="roundRect">
-            <a:avLst>
-              <a:gd name="adj" fmla="val 2500"/>
-            </a:avLst>
-          </a:prstGeom>
-          <a:solidFill>
-            <a:srgbClr val="F0F0F0"/>
-          </a:solidFill>
-          <a:ln>
-            <a:noFill/>
-          </a:ln>
-        </p:spPr>
-      </p:sp>
-      <p:sp>
-        <p:nvSpPr>
-          <p:cNvPr id="8" name="Box text"/>
-          <p:cNvSpPr>
-            <a:spLocks noGrp="1"/>
-          </p:cNvSpPr>
-          <p:nvPr>
-            <p:ph type="body" idx="11" hasCustomPrompt="1"/>
-          </p:nvPr>
-        </p:nvSpPr>
-        <p:spPr>
-          <a:xfrm>
-            <a:off x="1051560" y="3063240"/>
-            <a:ext cx="9539935" cy="2788920"/>
-          </a:xfrm>
-          <a:prstGeom prst="rect">
-            <a:avLst/>
-          </a:prstGeom>
-        </p:spPr>
-        <p:txBody>
-          <a:bodyPr wrap="square" lIns="0" tIns="0" rIns="0" bIns="0" anchor="t" rtlCol="0">
-            <a:normAutofit/>
-          </a:bodyPr>
-          <a:lstStyle>
-            <a:lvl1pPr marL="0" indent="0">
-              <a:lnSpc>
-                <a:spcPct val="130000"/>
-              </a:lnSpc>
-              <a:buNone/>
-              <a:defRPr lang="en-US" sz="1700"/>
-            </a:lvl1pPr>
-          </a:lstStyle>
-          <a:p>
-            <a:r>
-              <a:rPr lang="en-US"/>
-              <a:t>Supporting detail</a:t>
-            </a:r>
+            <a:endParaRPr lang="en-US"/>
           </a:p>
         </p:txBody>
       </p:sp>
@@ -3846,9 +3522,13 @@
       </p:pic>
       <p:sp>
         <p:nvSpPr>
-          <p:cNvPr id="6" name="Sidebar running title"/>
-          <p:cNvSpPr txBox="1"/>
-          <p:nvPr userDrawn="1"/>
+          <p:cNvPr id="6" name="Footer Placeholder"/>
+          <p:cNvSpPr>
+            <a:spLocks noGrp="1"/>
+          </p:cNvSpPr>
+          <p:nvPr>
+            <p:ph type="ftr" idx="11"/>
+          </p:nvPr>
         </p:nvSpPr>
         <p:spPr>
           <a:xfrm rot="16200000">
@@ -3858,22 +3538,23 @@
           <a:prstGeom prst="rect">
             <a:avLst/>
           </a:prstGeom>
-          <a:noFill/>
         </p:spPr>
         <p:txBody>
           <a:bodyPr wrap="square" lIns="0" tIns="0" rIns="0" bIns="0" anchor="ctr" rtlCol="0">
             <a:noAutofit/>
           </a:bodyPr>
-          <a:lstStyle/>
-          <a:p>
-            <a:r>
-              <a:rPr lang="en-US" sz="850" b="1" cap="all" spc="190">
+          <a:lstStyle>
+            <a:lvl1pPr marL="0" indent="0" algn="ctr">
+              <a:buNone/>
+              <a:defRPr lang="en-US" sz="850" b="1" cap="all" spc="190">
                 <a:solidFill>
                   <a:srgbClr val="FFFFFF"/>
                 </a:solidFill>
-              </a:rPr>
-              <a:t>UNAIR PowerPoint Template</a:t>
-            </a:r>
+              </a:defRPr>
+            </a:lvl1pPr>
+          </a:lstStyle>
+          <a:p>
+            <a:endParaRPr lang="en-US"/>
           </a:p>
         </p:txBody>
       </p:sp>
@@ -3942,21 +3623,23 @@
   </p:cSld>
   <p:clrMap bg1="lt1" tx1="dk1" bg2="lt2" tx2="dk2" accent1="accent1" accent2="accent2" accent3="accent3" accent4="accent4" accent5="accent5" accent6="accent6" hlink="hlink" folHlink="folHlink"/>
   <p:sldLayoutIdLst>
-    <p:sldLayoutId id="2147483715" r:id="rId3"/>
-    <p:sldLayoutId id="2147483716" r:id="rId4"/>
-    <p:sldLayoutId id="2147483717" r:id="rId5"/>
-    <p:sldLayoutId id="2147483718" r:id="rId6"/>
-    <p:sldLayoutId id="2147483719" r:id="rId7"/>
-    <p:sldLayoutId id="2147483720" r:id="rId8"/>
-    <p:sldLayoutId id="2147483721" r:id="rId9"/>
-    <p:sldLayoutId id="2147483722" r:id="rId10"/>
-    <p:sldLayoutId id="2147483723" r:id="rId11"/>
-    <p:sldLayoutId id="2147483724" r:id="rId1"/>
-    <p:sldLayoutId id="2147483725" r:id="rId13"/>
-    <p:sldLayoutId id="2147483726" r:id="rId14"/>
-    <p:sldLayoutId id="2147483727" r:id="rId15"/>
-    <p:sldLayoutId id="2147483728" r:id="rId16"/>
+    <p:sldLayoutId id="2147483716" r:id="rId3"/>
+    <p:sldLayoutId id="2147483717" r:id="rId4"/>
+    <p:sldLayoutId id="2147483718" r:id="rId5"/>
+    <p:sldLayoutId id="2147483719" r:id="rId6"/>
+    <p:sldLayoutId id="2147483720" r:id="rId7"/>
+    <p:sldLayoutId id="2147483721" r:id="rId8"/>
+    <p:sldLayoutId id="2147483722" r:id="rId9"/>
+    <p:sldLayoutId id="2147483723" r:id="rId10"/>
+    <p:sldLayoutId id="2147483724" r:id="rId11"/>
+    <p:sldLayoutId id="2147483725" r:id="rId1"/>
+    <p:sldLayoutId id="2147483726" r:id="rId13"/>
+    <p:sldLayoutId id="2147483727" r:id="rId14"/>
+    <p:sldLayoutId id="2147483728" r:id="rId15"/>
+    <p:sldLayoutId id="2147483729" r:id="rId16"/>
+    <p:sldLayoutId id="2147483730" r:id="rId17"/>
   </p:sldLayoutIdLst>
+  <p:hf sldNum="0" hdr="0" dt="0"/>
   <p:txStyles>
     <p:titleStyle>
       <a:lvl1pPr algn="l" defTabSz="914400" rtl="0" eaLnBrk="1" latinLnBrk="0" hangingPunct="1">
@@ -4434,7 +4117,7 @@
             <a:spLocks noGrp="1"/>
           </p:cNvSpPr>
           <p:nvPr>
-            <p:ph type="body" idx="10"/>
+            <p:ph type="body" idx="15"/>
           </p:nvPr>
         </p:nvSpPr>
         <p:spPr/>
@@ -4456,7 +4139,7 @@
             <a:spLocks noGrp="1"/>
           </p:cNvSpPr>
           <p:nvPr>
-            <p:ph type="body" idx="11"/>
+            <p:ph type="body" idx="16"/>
           </p:nvPr>
         </p:nvSpPr>
         <p:spPr/>
@@ -4467,6 +4150,28 @@
             <a:pPr/>
             <a:r>
               <a:t>This study examines how open science practices affect replication rates in psychological research, drawing on a pre-registered, multi-site design.</a:t>
+            </a:r>
+          </a:p>
+        </p:txBody>
+      </p:sp>
+      <p:sp>
+        <p:nvSpPr>
+          <p:cNvPr id="5" name="Footer Placeholder"/>
+          <p:cNvSpPr>
+            <a:spLocks noGrp="1"/>
+          </p:cNvSpPr>
+          <p:nvPr>
+            <p:ph type="ftr" idx="11"/>
+          </p:nvPr>
+        </p:nvSpPr>
+        <p:spPr/>
+        <p:txBody>
+          <a:bodyPr/>
+          <a:lstStyle/>
+          <a:p>
+            <a:r>
+              <a:rPr lang="en-US"/>
+              <a:t>UNAIR PowerPoint Template</a:t>
             </a:r>
           </a:p>
         </p:txBody>
@@ -4533,33 +4238,14 @@
           </a:p>
         </p:txBody>
       </p:sp>
-      <p:pic>
-        <p:nvPicPr>
-          <p:cNvPr id="4" name="Picture Placeholder 3" descr="FaGraduationCap.png"/>
-          <p:cNvPicPr>
-            <a:picLocks noGrp="1" noChangeAspect="1"/>
-          </p:cNvPicPr>
-          <p:nvPr>
-            <p:ph type="pic" idx="30"/>
-          </p:nvPr>
-        </p:nvPicPr>
-        <p:blipFill>
-          <a:blip r:embed="rId2"/>
-          <a:srcRect/>
-          <a:stretch>
-            <a:fillRect/>
-          </a:stretch>
-        </p:blipFill>
-        <p:spPr/>
-      </p:pic>
-      <p:sp>
-        <p:nvSpPr>
-          <p:cNvPr id="5" name="Text Placeholder 4"/>
-          <p:cNvSpPr>
-            <a:spLocks noGrp="1"/>
-          </p:cNvSpPr>
-          <p:nvPr>
-            <p:ph type="body" idx="40"/>
+      <p:sp>
+        <p:nvSpPr>
+          <p:cNvPr id="5" name="Footer Placeholder"/>
+          <p:cNvSpPr>
+            <a:spLocks noGrp="1"/>
+          </p:cNvSpPr>
+          <p:nvPr>
+            <p:ph type="ftr" idx="11"/>
           </p:nvPr>
         </p:nvSpPr>
         <p:spPr/>
@@ -4567,161 +4253,253 @@
           <a:bodyPr/>
           <a:lstStyle/>
           <a:p>
-            <a:pPr/>
-            <a:r>
-              <a:t>Rigor</a:t>
-            </a:r>
-          </a:p>
-        </p:txBody>
-      </p:sp>
-      <p:sp>
-        <p:nvSpPr>
-          <p:cNvPr id="6" name="Text Placeholder 5"/>
-          <p:cNvSpPr>
-            <a:spLocks noGrp="1"/>
-          </p:cNvSpPr>
-          <p:nvPr>
-            <p:ph type="body" idx="50"/>
-          </p:nvPr>
-        </p:nvSpPr>
-        <p:spPr/>
-        <p:txBody>
-          <a:bodyPr/>
-          <a:lstStyle/>
-          <a:p>
-            <a:pPr/>
-            <a:r>
-              <a:t>Pre-registered designs and transparent analysis pipelines.</a:t>
-            </a:r>
-          </a:p>
-        </p:txBody>
-      </p:sp>
-      <p:pic>
-        <p:nvPicPr>
-          <p:cNvPr id="7" name="Picture Placeholder 6" descr="FaHandshake.png"/>
-          <p:cNvPicPr>
-            <a:picLocks noGrp="1" noChangeAspect="1"/>
-          </p:cNvPicPr>
-          <p:nvPr>
-            <p:ph type="pic" idx="31"/>
-          </p:nvPr>
-        </p:nvPicPr>
-        <p:blipFill>
-          <a:blip r:embed="rId3"/>
-          <a:srcRect/>
-          <a:stretch>
-            <a:fillRect/>
-          </a:stretch>
-        </p:blipFill>
-        <p:spPr/>
-      </p:pic>
-      <p:sp>
-        <p:nvSpPr>
-          <p:cNvPr id="8" name="Text Placeholder 7"/>
-          <p:cNvSpPr>
-            <a:spLocks noGrp="1"/>
-          </p:cNvSpPr>
-          <p:nvPr>
-            <p:ph type="body" idx="41"/>
-          </p:nvPr>
-        </p:nvSpPr>
-        <p:spPr/>
-        <p:txBody>
-          <a:bodyPr/>
-          <a:lstStyle/>
-          <a:p>
-            <a:pPr/>
-            <a:r>
-              <a:t>Collaboration</a:t>
-            </a:r>
-          </a:p>
-        </p:txBody>
-      </p:sp>
-      <p:sp>
-        <p:nvSpPr>
-          <p:cNvPr id="9" name="Text Placeholder 8"/>
-          <p:cNvSpPr>
-            <a:spLocks noGrp="1"/>
-          </p:cNvSpPr>
-          <p:nvPr>
-            <p:ph type="body" idx="51"/>
-          </p:nvPr>
-        </p:nvSpPr>
-        <p:spPr/>
-        <p:txBody>
-          <a:bodyPr/>
-          <a:lstStyle/>
-          <a:p>
-            <a:pPr/>
-            <a:r>
-              <a:t>Multi-site partnerships across Indonesian universities.</a:t>
-            </a:r>
-          </a:p>
-        </p:txBody>
-      </p:sp>
-      <p:pic>
-        <p:nvPicPr>
-          <p:cNvPr id="10" name="Picture Placeholder 9" descr="FaChartBar.png"/>
-          <p:cNvPicPr>
-            <a:picLocks noGrp="1" noChangeAspect="1"/>
-          </p:cNvPicPr>
-          <p:nvPr>
-            <p:ph type="pic" idx="32"/>
-          </p:nvPr>
-        </p:nvPicPr>
-        <p:blipFill>
-          <a:blip r:embed="rId4"/>
-          <a:srcRect/>
-          <a:stretch>
-            <a:fillRect/>
-          </a:stretch>
-        </p:blipFill>
-        <p:spPr/>
-      </p:pic>
-      <p:sp>
-        <p:nvSpPr>
-          <p:cNvPr id="11" name="Text Placeholder 10"/>
-          <p:cNvSpPr>
-            <a:spLocks noGrp="1"/>
-          </p:cNvSpPr>
-          <p:nvPr>
-            <p:ph type="body" idx="42"/>
-          </p:nvPr>
-        </p:nvSpPr>
-        <p:spPr/>
-        <p:txBody>
-          <a:bodyPr/>
-          <a:lstStyle/>
-          <a:p>
-            <a:pPr/>
-            <a:r>
-              <a:t>Openness</a:t>
-            </a:r>
-          </a:p>
-        </p:txBody>
-      </p:sp>
-      <p:sp>
-        <p:nvSpPr>
-          <p:cNvPr id="12" name="Text Placeholder 11"/>
-          <p:cNvSpPr>
-            <a:spLocks noGrp="1"/>
-          </p:cNvSpPr>
-          <p:nvPr>
-            <p:ph type="body" idx="52"/>
-          </p:nvPr>
-        </p:nvSpPr>
-        <p:spPr/>
-        <p:txBody>
-          <a:bodyPr/>
-          <a:lstStyle/>
-          <a:p>
-            <a:pPr/>
-            <a:r>
-              <a:t>Data, code, and materials shared on publication.</a:t>
-            </a:r>
-          </a:p>
-        </p:txBody>
-      </p:sp>
+            <a:r>
+              <a:rPr lang="en-US"/>
+              <a:t>UNAIR PowerPoint Template</a:t>
+            </a:r>
+          </a:p>
+        </p:txBody>
+      </p:sp>
+      <p:graphicFrame>
+        <p:nvGraphicFramePr>
+          <p:cNvPr id="6" name="Table 5"/>
+          <p:cNvGraphicFramePr>
+            <a:graphicFrameLocks noGrp="1"/>
+          </p:cNvGraphicFramePr>
+          <p:nvPr/>
+        </p:nvGraphicFramePr>
+        <p:xfrm>
+          <a:off x="548640" y="2286000"/>
+          <a:ext cx="10545775" cy="4023360"/>
+        </p:xfrm>
+        <a:graphic>
+          <a:graphicData uri="http://schemas.openxmlformats.org/drawingml/2006/table">
+            <a:tbl>
+              <a:tblPr>
+                <a:tableStyleId>{2D5ABB26-0587-4C30-8999-92F81FD0307C}</a:tableStyleId>
+              </a:tblPr>
+              <a:tblGrid>
+                <a:gridCol w="3515258"/>
+                <a:gridCol w="3515258"/>
+                <a:gridCol w="3515259"/>
+              </a:tblGrid>
+              <a:tr h="1207008">
+                <a:tc>
+                  <a:txBody>
+                    <a:bodyPr/>
+                    <a:lstStyle/>
+                    <a:p>
+                      <a:pPr algn="ctr"/>
+                      <a:r>
+                        <a:rPr sz="3200" b="0">
+                          <a:solidFill>
+                            <a:srgbClr val="333333"/>
+                          </a:solidFill>
+                          <a:latin typeface="Segoe UI Emoji"/>
+                        </a:rPr>
+                        <a:t>🎓</a:t>
+                      </a:r>
+                    </a:p>
+                  </a:txBody>
+                  <a:tcPr marL="228600" marR="228600" marT="0" marB="0" anchor="ctr">
+                    <a:solidFill>
+                      <a:srgbClr val="F0F0F0"/>
+                    </a:solidFill>
+                  </a:tcPr>
+                </a:tc>
+                <a:tc>
+                  <a:txBody>
+                    <a:bodyPr/>
+                    <a:lstStyle/>
+                    <a:p>
+                      <a:pPr algn="ctr"/>
+                      <a:r>
+                        <a:rPr sz="3200" b="0">
+                          <a:solidFill>
+                            <a:srgbClr val="333333"/>
+                          </a:solidFill>
+                          <a:latin typeface="Segoe UI Emoji"/>
+                        </a:rPr>
+                        <a:t>🤝</a:t>
+                      </a:r>
+                    </a:p>
+                  </a:txBody>
+                  <a:tcPr marL="228600" marR="228600" marT="0" marB="0" anchor="ctr">
+                    <a:solidFill>
+                      <a:srgbClr val="F0F0F0"/>
+                    </a:solidFill>
+                  </a:tcPr>
+                </a:tc>
+                <a:tc>
+                  <a:txBody>
+                    <a:bodyPr/>
+                    <a:lstStyle/>
+                    <a:p>
+                      <a:pPr algn="ctr"/>
+                      <a:r>
+                        <a:rPr sz="3200" b="0">
+                          <a:solidFill>
+                            <a:srgbClr val="333333"/>
+                          </a:solidFill>
+                          <a:latin typeface="Segoe UI Emoji"/>
+                        </a:rPr>
+                        <a:t>📊</a:t>
+                      </a:r>
+                    </a:p>
+                  </a:txBody>
+                  <a:tcPr marL="228600" marR="228600" marT="0" marB="0" anchor="ctr">
+                    <a:solidFill>
+                      <a:srgbClr val="F0F0F0"/>
+                    </a:solidFill>
+                  </a:tcPr>
+                </a:tc>
+              </a:tr>
+              <a:tr h="804672">
+                <a:tc>
+                  <a:txBody>
+                    <a:bodyPr/>
+                    <a:lstStyle/>
+                    <a:p>
+                      <a:pPr algn="ctr"/>
+                      <a:r>
+                        <a:rPr sz="1700" b="1">
+                          <a:solidFill>
+                            <a:srgbClr val="14497F"/>
+                          </a:solidFill>
+                          <a:latin typeface="Segoe UI"/>
+                        </a:rPr>
+                        <a:t>Rigor</a:t>
+                      </a:r>
+                    </a:p>
+                  </a:txBody>
+                  <a:tcPr marL="228600" marR="228600" marT="0" marB="0" anchor="ctr">
+                    <a:solidFill>
+                      <a:srgbClr val="F0F0F0"/>
+                    </a:solidFill>
+                  </a:tcPr>
+                </a:tc>
+                <a:tc>
+                  <a:txBody>
+                    <a:bodyPr/>
+                    <a:lstStyle/>
+                    <a:p>
+                      <a:pPr algn="ctr"/>
+                      <a:r>
+                        <a:rPr sz="1700" b="1">
+                          <a:solidFill>
+                            <a:srgbClr val="14497F"/>
+                          </a:solidFill>
+                          <a:latin typeface="Segoe UI"/>
+                        </a:rPr>
+                        <a:t>Collaboration</a:t>
+                      </a:r>
+                    </a:p>
+                  </a:txBody>
+                  <a:tcPr marL="228600" marR="228600" marT="0" marB="0" anchor="ctr">
+                    <a:solidFill>
+                      <a:srgbClr val="F0F0F0"/>
+                    </a:solidFill>
+                  </a:tcPr>
+                </a:tc>
+                <a:tc>
+                  <a:txBody>
+                    <a:bodyPr/>
+                    <a:lstStyle/>
+                    <a:p>
+                      <a:pPr algn="ctr"/>
+                      <a:r>
+                        <a:rPr sz="1700" b="1">
+                          <a:solidFill>
+                            <a:srgbClr val="14497F"/>
+                          </a:solidFill>
+                          <a:latin typeface="Segoe UI"/>
+                        </a:rPr>
+                        <a:t>Openness</a:t>
+                      </a:r>
+                    </a:p>
+                  </a:txBody>
+                  <a:tcPr marL="228600" marR="228600" marT="0" marB="0" anchor="ctr">
+                    <a:solidFill>
+                      <a:srgbClr val="F0F0F0"/>
+                    </a:solidFill>
+                  </a:tcPr>
+                </a:tc>
+              </a:tr>
+              <a:tr h="2011680">
+                <a:tc>
+                  <a:txBody>
+                    <a:bodyPr/>
+                    <a:lstStyle/>
+                    <a:p>
+                      <a:pPr algn="ctr"/>
+                      <a:r>
+                        <a:rPr sz="1400" b="0">
+                          <a:solidFill>
+                            <a:srgbClr val="333333"/>
+                          </a:solidFill>
+                          <a:latin typeface="Segoe UI"/>
+                        </a:rPr>
+                        <a:t>Pre-registered designs and transparent analysis pipelines.</a:t>
+                      </a:r>
+                    </a:p>
+                  </a:txBody>
+                  <a:tcPr marL="228600" marR="228600" marT="0" marB="0" anchor="ctr">
+                    <a:solidFill>
+                      <a:srgbClr val="F0F0F0"/>
+                    </a:solidFill>
+                  </a:tcPr>
+                </a:tc>
+                <a:tc>
+                  <a:txBody>
+                    <a:bodyPr/>
+                    <a:lstStyle/>
+                    <a:p>
+                      <a:pPr algn="ctr"/>
+                      <a:r>
+                        <a:rPr sz="1400" b="0">
+                          <a:solidFill>
+                            <a:srgbClr val="333333"/>
+                          </a:solidFill>
+                          <a:latin typeface="Segoe UI"/>
+                        </a:rPr>
+                        <a:t>Multi-site partnerships across Indonesian universities.</a:t>
+                      </a:r>
+                    </a:p>
+                  </a:txBody>
+                  <a:tcPr marL="228600" marR="228600" marT="0" marB="0" anchor="ctr">
+                    <a:solidFill>
+                      <a:srgbClr val="F0F0F0"/>
+                    </a:solidFill>
+                  </a:tcPr>
+                </a:tc>
+                <a:tc>
+                  <a:txBody>
+                    <a:bodyPr/>
+                    <a:lstStyle/>
+                    <a:p>
+                      <a:pPr algn="ctr"/>
+                      <a:r>
+                        <a:rPr sz="1400" b="0">
+                          <a:solidFill>
+                            <a:srgbClr val="333333"/>
+                          </a:solidFill>
+                          <a:latin typeface="Segoe UI"/>
+                        </a:rPr>
+                        <a:t>Data, code, and materials shared on publication.</a:t>
+                      </a:r>
+                    </a:p>
+                  </a:txBody>
+                  <a:tcPr marL="228600" marR="228600" marT="0" marB="0" anchor="ctr">
+                    <a:solidFill>
+                      <a:srgbClr val="F0F0F0"/>
+                    </a:solidFill>
+                  </a:tcPr>
+                </a:tc>
+              </a:tr>
+            </a:tbl>
+          </a:graphicData>
+        </a:graphic>
+      </p:graphicFrame>
     </p:spTree>
   </p:cSld>
   <p:clrMapOvr>
@@ -4769,7 +4547,7 @@
             <a:picLocks noGrp="1" noChangeAspect="1"/>
           </p:cNvPicPr>
           <p:nvPr>
-            <p:ph type="pic" idx="10"/>
+            <p:ph type="pic" idx="15"/>
           </p:nvPr>
         </p:nvPicPr>
         <p:blipFill>
@@ -4810,7 +4588,7 @@
             <a:picLocks noGrp="1" noChangeAspect="1"/>
           </p:cNvPicPr>
           <p:nvPr>
-            <p:ph type="pic" idx="11"/>
+            <p:ph type="pic" idx="16"/>
           </p:nvPr>
         </p:nvPicPr>
         <p:blipFill>
@@ -4851,7 +4629,7 @@
             <a:picLocks noGrp="1" noChangeAspect="1"/>
           </p:cNvPicPr>
           <p:nvPr>
-            <p:ph type="pic" idx="12"/>
+            <p:ph type="pic" idx="17"/>
           </p:nvPr>
         </p:nvPicPr>
         <p:blipFill>
@@ -4881,6 +4659,28 @@
             <a:pPr/>
             <a:r>
               <a:t>Student Life</a:t>
+            </a:r>
+          </a:p>
+        </p:txBody>
+      </p:sp>
+      <p:sp>
+        <p:nvSpPr>
+          <p:cNvPr id="9" name="Footer Placeholder"/>
+          <p:cNvSpPr>
+            <a:spLocks noGrp="1"/>
+          </p:cNvSpPr>
+          <p:nvPr>
+            <p:ph type="ftr" idx="11"/>
+          </p:nvPr>
+        </p:nvSpPr>
+        <p:spPr/>
+        <p:txBody>
+          <a:bodyPr/>
+          <a:lstStyle/>
+          <a:p>
+            <a:r>
+              <a:rPr lang="en-US"/>
+              <a:t>UNAIR PowerPoint Template</a:t>
             </a:r>
           </a:p>
         </p:txBody>
@@ -4905,12 +4705,12 @@
       <p:grpSpPr/>
       <p:sp>
         <p:nvSpPr>
-          <p:cNvPr id="2" name="Text Placeholder 1"/>
-          <p:cNvSpPr>
-            <a:spLocks noGrp="1"/>
-          </p:cNvSpPr>
-          <p:nvPr>
-            <p:ph type="body" idx="10"/>
+          <p:cNvPr id="2" name="Title 1"/>
+          <p:cNvSpPr>
+            <a:spLocks noGrp="1"/>
+          </p:cNvSpPr>
+          <p:nvPr>
+            <p:ph type="title"/>
           </p:nvPr>
         </p:nvSpPr>
         <p:spPr/>
@@ -4920,6 +4720,28 @@
           <a:p>
             <a:pPr/>
             <a:r>
+              <a:t>On what counts</a:t>
+            </a:r>
+          </a:p>
+        </p:txBody>
+      </p:sp>
+      <p:sp>
+        <p:nvSpPr>
+          <p:cNvPr id="3" name="Text Placeholder 2"/>
+          <p:cNvSpPr>
+            <a:spLocks noGrp="1"/>
+          </p:cNvSpPr>
+          <p:nvPr>
+            <p:ph type="body" idx="10"/>
+          </p:nvPr>
+        </p:nvSpPr>
+        <p:spPr/>
+        <p:txBody>
+          <a:bodyPr/>
+          <a:lstStyle/>
+          <a:p>
+            <a:pPr/>
+            <a:r>
               <a:t>Not everything that counts can be counted, and not everything that can be counted counts.</a:t>
             </a:r>
           </a:p>
@@ -4927,7 +4749,7 @@
       </p:sp>
       <p:sp>
         <p:nvSpPr>
-          <p:cNvPr id="3" name="Text Placeholder 2"/>
+          <p:cNvPr id="4" name="Text Placeholder 3"/>
           <p:cNvSpPr>
             <a:spLocks noGrp="1"/>
           </p:cNvSpPr>
@@ -4979,12 +4801,12 @@
       <p:grpSpPr/>
       <p:sp>
         <p:nvSpPr>
-          <p:cNvPr id="2" name="Text Placeholder 1"/>
-          <p:cNvSpPr>
-            <a:spLocks noGrp="1"/>
-          </p:cNvSpPr>
-          <p:nvPr>
-            <p:ph type="body" idx="10"/>
+          <p:cNvPr id="2" name="Title 1"/>
+          <p:cNvSpPr>
+            <a:spLocks noGrp="1"/>
+          </p:cNvSpPr>
+          <p:nvPr>
+            <p:ph type="title"/>
           </p:nvPr>
         </p:nvSpPr>
         <p:spPr/>
@@ -4994,6 +4816,28 @@
           <a:p>
             <a:pPr/>
             <a:r>
+              <a:t>Campbell's law</a:t>
+            </a:r>
+          </a:p>
+        </p:txBody>
+      </p:sp>
+      <p:sp>
+        <p:nvSpPr>
+          <p:cNvPr id="3" name="Text Placeholder 2"/>
+          <p:cNvSpPr>
+            <a:spLocks noGrp="1"/>
+          </p:cNvSpPr>
+          <p:nvPr>
+            <p:ph type="body" idx="10"/>
+          </p:nvPr>
+        </p:nvSpPr>
+        <p:spPr/>
+        <p:txBody>
+          <a:bodyPr/>
+          <a:lstStyle/>
+          <a:p>
+            <a:pPr/>
+            <a:r>
               <a:t>The more any quantitative social indicator is used for social decision-making, the more subject it will be to corruption pressures.</a:t>
             </a:r>
           </a:p>
@@ -5001,7 +4845,7 @@
       </p:sp>
       <p:sp>
         <p:nvSpPr>
-          <p:cNvPr id="3" name="Text Placeholder 2"/>
+          <p:cNvPr id="4" name="Text Placeholder 3"/>
           <p:cNvSpPr>
             <a:spLocks noGrp="1"/>
           </p:cNvSpPr>
@@ -5186,7 +5030,7 @@
             <a:spLocks noGrp="1"/>
           </p:cNvSpPr>
           <p:nvPr>
-            <p:ph type="body" idx="20"/>
+            <p:ph type="body" idx="1"/>
           </p:nvPr>
         </p:nvSpPr>
         <p:spPr/>
@@ -5199,88 +5043,24 @@
               <a:t>Background &amp; Motivation</a:t>
             </a:r>
           </a:p>
-        </p:txBody>
-      </p:sp>
-      <p:sp>
-        <p:nvSpPr>
-          <p:cNvPr id="4" name="Text Placeholder 3"/>
-          <p:cNvSpPr>
-            <a:spLocks noGrp="1"/>
-          </p:cNvSpPr>
-          <p:nvPr>
-            <p:ph type="body" idx="21"/>
-          </p:nvPr>
-        </p:nvSpPr>
-        <p:spPr/>
-        <p:txBody>
-          <a:bodyPr/>
-          <a:lstStyle/>
           <a:p>
             <a:pPr/>
             <a:r>
               <a:t>Research Methodology</a:t>
             </a:r>
           </a:p>
-        </p:txBody>
-      </p:sp>
-      <p:sp>
-        <p:nvSpPr>
-          <p:cNvPr id="5" name="Text Placeholder 4"/>
-          <p:cNvSpPr>
-            <a:spLocks noGrp="1"/>
-          </p:cNvSpPr>
-          <p:nvPr>
-            <p:ph type="body" idx="22"/>
-          </p:nvPr>
-        </p:nvSpPr>
-        <p:spPr/>
-        <p:txBody>
-          <a:bodyPr/>
-          <a:lstStyle/>
           <a:p>
             <a:pPr/>
             <a:r>
               <a:t>Findings &amp; Discussion</a:t>
             </a:r>
           </a:p>
-        </p:txBody>
-      </p:sp>
-      <p:sp>
-        <p:nvSpPr>
-          <p:cNvPr id="6" name="Text Placeholder 5"/>
-          <p:cNvSpPr>
-            <a:spLocks noGrp="1"/>
-          </p:cNvSpPr>
-          <p:nvPr>
-            <p:ph type="body" idx="23"/>
-          </p:nvPr>
-        </p:nvSpPr>
-        <p:spPr/>
-        <p:txBody>
-          <a:bodyPr/>
-          <a:lstStyle/>
           <a:p>
             <a:pPr/>
             <a:r>
               <a:t>Conclusions</a:t>
             </a:r>
           </a:p>
-        </p:txBody>
-      </p:sp>
-      <p:sp>
-        <p:nvSpPr>
-          <p:cNvPr id="7" name="Text Placeholder 6"/>
-          <p:cNvSpPr>
-            <a:spLocks noGrp="1"/>
-          </p:cNvSpPr>
-          <p:nvPr>
-            <p:ph type="body" idx="24"/>
-          </p:nvPr>
-        </p:nvSpPr>
-        <p:spPr/>
-        <p:txBody>
-          <a:bodyPr/>
-          <a:lstStyle/>
           <a:p>
             <a:pPr/>
             <a:r>
@@ -5375,6 +5155,28 @@
           </a:p>
         </p:txBody>
       </p:sp>
+      <p:sp>
+        <p:nvSpPr>
+          <p:cNvPr id="4" name="Footer Placeholder"/>
+          <p:cNvSpPr>
+            <a:spLocks noGrp="1"/>
+          </p:cNvSpPr>
+          <p:nvPr>
+            <p:ph type="ftr" idx="11"/>
+          </p:nvPr>
+        </p:nvSpPr>
+        <p:spPr/>
+        <p:txBody>
+          <a:bodyPr/>
+          <a:lstStyle/>
+          <a:p>
+            <a:r>
+              <a:rPr lang="en-US"/>
+              <a:t>UNAIR PowerPoint Template</a:t>
+            </a:r>
+          </a:p>
+        </p:txBody>
+      </p:sp>
     </p:spTree>
   </p:cSld>
   <p:clrMapOvr>
@@ -5509,6 +5311,28 @@
           </a:p>
         </p:txBody>
       </p:sp>
+      <p:sp>
+        <p:nvSpPr>
+          <p:cNvPr id="5" name="Footer Placeholder"/>
+          <p:cNvSpPr>
+            <a:spLocks noGrp="1"/>
+          </p:cNvSpPr>
+          <p:nvPr>
+            <p:ph type="ftr" idx="11"/>
+          </p:nvPr>
+        </p:nvSpPr>
+        <p:spPr/>
+        <p:txBody>
+          <a:bodyPr/>
+          <a:lstStyle/>
+          <a:p>
+            <a:r>
+              <a:rPr lang="en-US"/>
+              <a:t>UNAIR PowerPoint Template</a:t>
+            </a:r>
+          </a:p>
+        </p:txBody>
+      </p:sp>
     </p:spTree>
   </p:cSld>
   <p:clrMapOvr>
@@ -5635,7 +5459,29 @@
       </p:sp>
       <p:sp>
         <p:nvSpPr>
-          <p:cNvPr id="3" name="Rounded Rectangle 2"/>
+          <p:cNvPr id="3" name="Footer Placeholder"/>
+          <p:cNvSpPr>
+            <a:spLocks noGrp="1"/>
+          </p:cNvSpPr>
+          <p:nvPr>
+            <p:ph type="ftr" idx="11"/>
+          </p:nvPr>
+        </p:nvSpPr>
+        <p:spPr/>
+        <p:txBody>
+          <a:bodyPr/>
+          <a:lstStyle/>
+          <a:p>
+            <a:r>
+              <a:rPr lang="en-US"/>
+              <a:t>UNAIR PowerPoint Template</a:t>
+            </a:r>
+          </a:p>
+        </p:txBody>
+      </p:sp>
+      <p:sp>
+        <p:nvSpPr>
+          <p:cNvPr id="4" name="Rounded Rectangle 3"/>
           <p:cNvSpPr/>
           <p:nvPr/>
         </p:nvSpPr>
@@ -5681,7 +5527,7 @@
       </p:sp>
       <p:sp>
         <p:nvSpPr>
-          <p:cNvPr id="4" name="TextBox 3"/>
+          <p:cNvPr id="5" name="TextBox 4"/>
           <p:cNvSpPr txBox="1"/>
           <p:nvPr/>
         </p:nvSpPr>
@@ -5726,7 +5572,7 @@
       </p:sp>
       <p:sp>
         <p:nvSpPr>
-          <p:cNvPr id="5" name="Rounded Rectangle 4"/>
+          <p:cNvPr id="6" name="Rounded Rectangle 5"/>
           <p:cNvSpPr/>
           <p:nvPr/>
         </p:nvSpPr>
@@ -5772,7 +5618,7 @@
       </p:sp>
       <p:sp>
         <p:nvSpPr>
-          <p:cNvPr id="6" name="TextBox 5"/>
+          <p:cNvPr id="7" name="TextBox 6"/>
           <p:cNvSpPr txBox="1"/>
           <p:nvPr/>
         </p:nvSpPr>
@@ -5817,7 +5663,7 @@
       </p:sp>
       <p:sp>
         <p:nvSpPr>
-          <p:cNvPr id="7" name="Rounded Rectangle 6"/>
+          <p:cNvPr id="8" name="Rounded Rectangle 7"/>
           <p:cNvSpPr/>
           <p:nvPr/>
         </p:nvSpPr>
@@ -5863,7 +5709,7 @@
       </p:sp>
       <p:sp>
         <p:nvSpPr>
-          <p:cNvPr id="8" name="TextBox 7"/>
+          <p:cNvPr id="9" name="TextBox 8"/>
           <p:cNvSpPr txBox="1"/>
           <p:nvPr/>
         </p:nvSpPr>
@@ -5908,7 +5754,7 @@
       </p:sp>
       <p:sp>
         <p:nvSpPr>
-          <p:cNvPr id="9" name="Rounded Rectangle 8"/>
+          <p:cNvPr id="10" name="Rounded Rectangle 9"/>
           <p:cNvSpPr/>
           <p:nvPr/>
         </p:nvSpPr>
@@ -5954,7 +5800,7 @@
       </p:sp>
       <p:sp>
         <p:nvSpPr>
-          <p:cNvPr id="10" name="TextBox 9"/>
+          <p:cNvPr id="11" name="TextBox 10"/>
           <p:cNvSpPr txBox="1"/>
           <p:nvPr/>
         </p:nvSpPr>
@@ -6037,9 +5883,31 @@
           </a:p>
         </p:txBody>
       </p:sp>
+      <p:sp>
+        <p:nvSpPr>
+          <p:cNvPr id="3" name="Footer Placeholder"/>
+          <p:cNvSpPr>
+            <a:spLocks noGrp="1"/>
+          </p:cNvSpPr>
+          <p:nvPr>
+            <p:ph type="ftr" idx="11"/>
+          </p:nvPr>
+        </p:nvSpPr>
+        <p:spPr/>
+        <p:txBody>
+          <a:bodyPr/>
+          <a:lstStyle/>
+          <a:p>
+            <a:r>
+              <a:rPr lang="en-US"/>
+              <a:t>UNAIR PowerPoint Template</a:t>
+            </a:r>
+          </a:p>
+        </p:txBody>
+      </p:sp>
       <p:graphicFrame>
         <p:nvGraphicFramePr>
-          <p:cNvPr id="3" name="Table 2"/>
+          <p:cNvPr id="4" name="Table 3"/>
           <p:cNvGraphicFramePr>
             <a:graphicFrameLocks noGrp="1"/>
           </p:cNvGraphicFramePr>
@@ -6283,7 +6151,7 @@
       </p:graphicFrame>
       <p:sp>
         <p:nvSpPr>
-          <p:cNvPr id="4" name="TextBox 3"/>
+          <p:cNvPr id="5" name="TextBox 4"/>
           <p:cNvSpPr txBox="1"/>
           <p:nvPr/>
         </p:nvSpPr>
@@ -6408,6 +6276,28 @@
           </a:p>
         </p:txBody>
       </p:sp>
+      <p:sp>
+        <p:nvSpPr>
+          <p:cNvPr id="5" name="Footer Placeholder"/>
+          <p:cNvSpPr>
+            <a:spLocks noGrp="1"/>
+          </p:cNvSpPr>
+          <p:nvPr>
+            <p:ph type="ftr" idx="11"/>
+          </p:nvPr>
+        </p:nvSpPr>
+        <p:spPr/>
+        <p:txBody>
+          <a:bodyPr/>
+          <a:lstStyle/>
+          <a:p>
+            <a:r>
+              <a:rPr lang="en-US"/>
+              <a:t>UNAIR PowerPoint Template</a:t>
+            </a:r>
+          </a:p>
+        </p:txBody>
+      </p:sp>
     </p:spTree>
   </p:cSld>
   <p:clrMapOvr>
@@ -6485,6 +6375,28 @@
             <a:pPr/>
             <a:r>
               <a:t>Field data were gathered across three sites using a standardized protocol, with inter-rater reliability checks throughout.</a:t>
+            </a:r>
+          </a:p>
+        </p:txBody>
+      </p:sp>
+      <p:sp>
+        <p:nvSpPr>
+          <p:cNvPr id="5" name="Footer Placeholder"/>
+          <p:cNvSpPr>
+            <a:spLocks noGrp="1"/>
+          </p:cNvSpPr>
+          <p:nvPr>
+            <p:ph type="ftr" idx="11"/>
+          </p:nvPr>
+        </p:nvSpPr>
+        <p:spPr/>
+        <p:txBody>
+          <a:bodyPr/>
+          <a:lstStyle/>
+          <a:p>
+            <a:r>
+              <a:rPr lang="en-US"/>
+              <a:t>UNAIR PowerPoint Template</a:t>
             </a:r>
           </a:p>
         </p:txBody>

</xml_diff>